<commit_message>
Vision par Ordinateur — Harris SIFT SURF ORB GLCM
</commit_message>
<xml_diff>
--- a/presentation_vision.pptx
+++ b/presentation_vision.pptx
@@ -4,6 +4,9 @@
   <p:sldMasterIdLst>
     <p:sldMasterId id="2147483648" r:id="rId1"/>
   </p:sldMasterIdLst>
+  <p:notesMasterIdLst>
+    <p:notesMasterId r:id="rId18"/>
+  </p:notesMasterIdLst>
   <p:sldIdLst>
     <p:sldId id="256" r:id="rId2"/>
     <p:sldId id="257" r:id="rId3"/>
@@ -22,10 +25,7 @@
     <p:sldId id="270" r:id="rId16"/>
     <p:sldId id="271" r:id="rId17"/>
   </p:sldIdLst>
-  <p:notesMasterIdLst>
-    <p:notesMasterId r:id="rId18"/>
-  </p:notesMasterIdLst>
-  <p:sldSz cx="9144000" cy="5143500"/>
+  <p:sldSz cx="9144000" cy="5143500" type="screen16x9"/>
   <p:notesSz cx="5143500" cy="9144000"/>
   <p:defaultTextStyle>
     <a:lvl1pPr marL="0" algn="l" defTabSz="914400" rtl="0" eaLnBrk="1" latinLnBrk="0" hangingPunct="1">
@@ -119,6 +119,11 @@
       </a:defRPr>
     </a:lvl9pPr>
   </p:defaultTextStyle>
+  <p:extLst>
+    <p:ext uri="{EFAFB233-063F-42B5-8137-9DF3F51BA10A}">
+      <p15:sldGuideLst xmlns:p15="http://schemas.microsoft.com/office/powerpoint/2012/main"/>
+    </p:ext>
+  </p:extLst>
 </p:presentation>
 </file>
 
@@ -144,234 +149,10 @@
           <a:chExt cx="0" cy="0"/>
         </a:xfrm>
       </p:grpSpPr>
-      <p:sp>
-        <p:nvSpPr>
-          <p:cNvPr id="2" name="Header Placeholder 1"/>
-          <p:cNvSpPr>
-            <a:spLocks noGrp="1"/>
-          </p:cNvSpPr>
-          <p:nvPr>
-            <p:ph type="hdr" sz="quarter"/>
-          </p:nvPr>
-        </p:nvSpPr>
-        <p:spPr>
-          <a:xfrm>
-            <a:off x="0" y="0"/>
-            <a:ext cx="2971800" cy="458788"/>
-          </a:xfrm>
-          <a:prstGeom prst="rect">
-            <a:avLst/>
-          </a:prstGeom>
-        </p:spPr>
-        <p:txBody>
-          <a:bodyPr vert="horz" lIns="91440" tIns="45720" rIns="91440" bIns="45720" rtlCol="0"/>
-          <a:lstStyle>
-            <a:lvl1pPr algn="l">
-              <a:defRPr sz="1200"/>
-            </a:lvl1pPr>
-          </a:lstStyle>
-          <a:p>
-            <a:endParaRPr lang="en-US"/>
-          </a:p>
-        </p:txBody>
-      </p:sp>
-      <p:sp>
-        <p:nvSpPr>
-          <p:cNvPr id="3" name="Date Placeholder 2"/>
-          <p:cNvSpPr>
-            <a:spLocks noGrp="1"/>
-          </p:cNvSpPr>
-          <p:nvPr>
-            <p:ph type="dt" idx="1"/>
-          </p:nvPr>
-        </p:nvSpPr>
-        <p:spPr>
-          <a:xfrm>
-            <a:off x="3884613" y="0"/>
-            <a:ext cx="2971800" cy="458788"/>
-          </a:xfrm>
-          <a:prstGeom prst="rect">
-            <a:avLst/>
-          </a:prstGeom>
-        </p:spPr>
-        <p:txBody>
-          <a:bodyPr vert="horz" lIns="91440" tIns="45720" rIns="91440" bIns="45720" rtlCol="0"/>
-          <a:lstStyle>
-            <a:lvl1pPr algn="r">
-              <a:defRPr sz="1200"/>
-            </a:lvl1pPr>
-          </a:lstStyle>
-          <a:p>
-            <a:fld id="{5282F153-3F37-0F45-9E97-73ACFA13230C}" type="datetimeFigureOut">
-              <a:rPr lang="en-US"/>
-              <a:t>7/23/19</a:t>
-            </a:fld>
-            <a:endParaRPr lang="en-US"/>
-          </a:p>
-        </p:txBody>
-      </p:sp>
-      <p:sp>
-        <p:nvSpPr>
-          <p:cNvPr id="4" name="Slide Image Placeholder 3"/>
-          <p:cNvSpPr>
-            <a:spLocks noGrp="1" noRot="1" noChangeAspect="1"/>
-          </p:cNvSpPr>
-          <p:nvPr>
-            <p:ph type="sldImg" idx="2"/>
-          </p:nvPr>
-        </p:nvSpPr>
-        <p:spPr>
-          <a:xfrm>
-            <a:off x="685800" y="1143000"/>
-            <a:ext cx="5486400" cy="3086100"/>
-          </a:xfrm>
-          <a:prstGeom prst="rect">
-            <a:avLst/>
-          </a:prstGeom>
-          <a:noFill/>
-          <a:ln w="12700">
-            <a:solidFill>
-              <a:prstClr val="black"/>
-            </a:solidFill>
-          </a:ln>
-        </p:spPr>
-        <p:txBody>
-          <a:bodyPr vert="horz" lIns="91440" tIns="45720" rIns="91440" bIns="45720" rtlCol="0" anchor="ctr"/>
-          <a:lstStyle/>
-          <a:p>
-            <a:endParaRPr lang="en-US"/>
-          </a:p>
-        </p:txBody>
-      </p:sp>
-      <p:sp>
-        <p:nvSpPr>
-          <p:cNvPr id="5" name="Notes Placeholder 4"/>
-          <p:cNvSpPr>
-            <a:spLocks noGrp="1"/>
-          </p:cNvSpPr>
-          <p:nvPr>
-            <p:ph type="body" sz="quarter" idx="3"/>
-          </p:nvPr>
-        </p:nvSpPr>
-        <p:spPr>
-          <a:xfrm>
-            <a:off x="685800" y="4400550"/>
-            <a:ext cx="5486400" cy="3600450"/>
-          </a:xfrm>
-          <a:prstGeom prst="rect">
-            <a:avLst/>
-          </a:prstGeom>
-        </p:spPr>
-        <p:txBody>
-          <a:bodyPr vert="horz" lIns="91440" tIns="45720" rIns="91440" bIns="45720" rtlCol="0"/>
-          <a:lstStyle/>
-          <a:p>
-            <a:pPr lvl="0"/>
-            <a:r>
-              <a:rPr lang="en-US"/>
-              <a:t>Click to edit Master text styles</a:t>
-            </a:r>
-          </a:p>
-          <a:p>
-            <a:pPr lvl="1"/>
-            <a:r>
-              <a:rPr lang="en-US"/>
-              <a:t>Second level</a:t>
-            </a:r>
-          </a:p>
-          <a:p>
-            <a:pPr lvl="2"/>
-            <a:r>
-              <a:rPr lang="en-US"/>
-              <a:t>Third level</a:t>
-            </a:r>
-          </a:p>
-          <a:p>
-            <a:pPr lvl="3"/>
-            <a:r>
-              <a:rPr lang="en-US"/>
-              <a:t>Fourth level</a:t>
-            </a:r>
-          </a:p>
-          <a:p>
-            <a:pPr lvl="4"/>
-            <a:r>
-              <a:rPr lang="en-US"/>
-              <a:t>Fifth level</a:t>
-            </a:r>
-          </a:p>
-        </p:txBody>
-      </p:sp>
-      <p:sp>
-        <p:nvSpPr>
-          <p:cNvPr id="6" name="Footer Placeholder 5"/>
-          <p:cNvSpPr>
-            <a:spLocks noGrp="1"/>
-          </p:cNvSpPr>
-          <p:nvPr>
-            <p:ph type="ftr" sz="quarter" idx="4"/>
-          </p:nvPr>
-        </p:nvSpPr>
-        <p:spPr>
-          <a:xfrm>
-            <a:off x="0" y="8685213"/>
-            <a:ext cx="2971800" cy="458787"/>
-          </a:xfrm>
-          <a:prstGeom prst="rect">
-            <a:avLst/>
-          </a:prstGeom>
-        </p:spPr>
-        <p:txBody>
-          <a:bodyPr vert="horz" lIns="91440" tIns="45720" rIns="91440" bIns="45720" rtlCol="0" anchor="b"/>
-          <a:lstStyle>
-            <a:lvl1pPr algn="l">
-              <a:defRPr sz="1200"/>
-            </a:lvl1pPr>
-          </a:lstStyle>
-          <a:p>
-            <a:endParaRPr lang="en-US"/>
-          </a:p>
-        </p:txBody>
-      </p:sp>
-      <p:sp>
-        <p:nvSpPr>
-          <p:cNvPr id="7" name="Slide Number Placeholder 6"/>
-          <p:cNvSpPr>
-            <a:spLocks noGrp="1"/>
-          </p:cNvSpPr>
-          <p:nvPr>
-            <p:ph type="sldNum" sz="quarter" idx="5"/>
-          </p:nvPr>
-        </p:nvSpPr>
-        <p:spPr>
-          <a:xfrm>
-            <a:off x="3884613" y="8685213"/>
-            <a:ext cx="2971800" cy="458787"/>
-          </a:xfrm>
-          <a:prstGeom prst="rect">
-            <a:avLst/>
-          </a:prstGeom>
-        </p:spPr>
-        <p:txBody>
-          <a:bodyPr vert="horz" lIns="91440" tIns="45720" rIns="91440" bIns="45720" rtlCol="0" anchor="b"/>
-          <a:lstStyle>
-            <a:lvl1pPr algn="r">
-              <a:defRPr sz="1200"/>
-            </a:lvl1pPr>
-          </a:lstStyle>
-          <a:p>
-            <a:fld id="{CE5E9CC1-C706-0F49-92D6-E571CC5EEA8F}" type="slidenum">
-              <a:rPr lang="en-US"/>
-              <a:t>‹#›</a:t>
-            </a:fld>
-            <a:endParaRPr lang="en-US"/>
-          </a:p>
-        </p:txBody>
-      </p:sp>
     </p:spTree>
     <p:extLst>
       <p:ext uri="{BB962C8B-B14F-4D97-AF65-F5344CB8AC3E}">
-        <p14:creationId xmlns:p14="http://schemas.microsoft.com/office/powerpoint/2010/main" val="1024086991"/>
+        <p14:creationId xmlns:p14="http://schemas.microsoft.com/office/powerpoint/2010/main" val="889433548"/>
       </p:ext>
     </p:extLst>
   </p:cSld>
@@ -515,10 +296,6 @@
           <a:bodyPr/>
           <a:lstStyle/>
           <a:p>
-            <a:r>
-              <a:rPr lang="en-US" dirty="0"/>
-              <a:t/>
-            </a:r>
             <a:endParaRPr lang="en-US" dirty="0"/>
           </a:p>
         </p:txBody>
@@ -603,10 +380,6 @@
           <a:bodyPr/>
           <a:lstStyle/>
           <a:p>
-            <a:r>
-              <a:rPr lang="en-US" dirty="0"/>
-              <a:t/>
-            </a:r>
             <a:endParaRPr lang="en-US" dirty="0"/>
           </a:p>
         </p:txBody>
@@ -691,10 +464,6 @@
           <a:bodyPr/>
           <a:lstStyle/>
           <a:p>
-            <a:r>
-              <a:rPr lang="en-US" dirty="0"/>
-              <a:t/>
-            </a:r>
             <a:endParaRPr lang="en-US" dirty="0"/>
           </a:p>
         </p:txBody>
@@ -779,10 +548,6 @@
           <a:bodyPr/>
           <a:lstStyle/>
           <a:p>
-            <a:r>
-              <a:rPr lang="en-US" dirty="0"/>
-              <a:t/>
-            </a:r>
             <a:endParaRPr lang="en-US" dirty="0"/>
           </a:p>
         </p:txBody>
@@ -867,10 +632,6 @@
           <a:bodyPr/>
           <a:lstStyle/>
           <a:p>
-            <a:r>
-              <a:rPr lang="en-US" dirty="0"/>
-              <a:t/>
-            </a:r>
             <a:endParaRPr lang="en-US" dirty="0"/>
           </a:p>
         </p:txBody>
@@ -955,10 +716,6 @@
           <a:bodyPr/>
           <a:lstStyle/>
           <a:p>
-            <a:r>
-              <a:rPr lang="en-US" dirty="0"/>
-              <a:t/>
-            </a:r>
             <a:endParaRPr lang="en-US" dirty="0"/>
           </a:p>
         </p:txBody>
@@ -1043,10 +800,6 @@
           <a:bodyPr/>
           <a:lstStyle/>
           <a:p>
-            <a:r>
-              <a:rPr lang="en-US" dirty="0"/>
-              <a:t/>
-            </a:r>
             <a:endParaRPr lang="en-US" dirty="0"/>
           </a:p>
         </p:txBody>
@@ -1131,10 +884,6 @@
           <a:bodyPr/>
           <a:lstStyle/>
           <a:p>
-            <a:r>
-              <a:rPr lang="en-US" dirty="0"/>
-              <a:t/>
-            </a:r>
             <a:endParaRPr lang="en-US" dirty="0"/>
           </a:p>
         </p:txBody>
@@ -1219,10 +968,6 @@
           <a:bodyPr/>
           <a:lstStyle/>
           <a:p>
-            <a:r>
-              <a:rPr lang="en-US" dirty="0"/>
-              <a:t/>
-            </a:r>
             <a:endParaRPr lang="en-US" dirty="0"/>
           </a:p>
         </p:txBody>
@@ -1307,10 +1052,6 @@
           <a:bodyPr/>
           <a:lstStyle/>
           <a:p>
-            <a:r>
-              <a:rPr lang="en-US" dirty="0"/>
-              <a:t/>
-            </a:r>
             <a:endParaRPr lang="en-US" dirty="0"/>
           </a:p>
         </p:txBody>
@@ -1395,10 +1136,6 @@
           <a:bodyPr/>
           <a:lstStyle/>
           <a:p>
-            <a:r>
-              <a:rPr lang="en-US" dirty="0"/>
-              <a:t/>
-            </a:r>
             <a:endParaRPr lang="en-US" dirty="0"/>
           </a:p>
         </p:txBody>
@@ -1483,10 +1220,6 @@
           <a:bodyPr/>
           <a:lstStyle/>
           <a:p>
-            <a:r>
-              <a:rPr lang="en-US" dirty="0"/>
-              <a:t/>
-            </a:r>
             <a:endParaRPr lang="en-US" dirty="0"/>
           </a:p>
         </p:txBody>
@@ -1571,10 +1304,6 @@
           <a:bodyPr/>
           <a:lstStyle/>
           <a:p>
-            <a:r>
-              <a:rPr lang="en-US" dirty="0"/>
-              <a:t/>
-            </a:r>
             <a:endParaRPr lang="en-US" dirty="0"/>
           </a:p>
         </p:txBody>
@@ -1659,10 +1388,6 @@
           <a:bodyPr/>
           <a:lstStyle/>
           <a:p>
-            <a:r>
-              <a:rPr lang="en-US" dirty="0"/>
-              <a:t/>
-            </a:r>
             <a:endParaRPr lang="en-US" dirty="0"/>
           </a:p>
         </p:txBody>
@@ -1747,10 +1472,6 @@
           <a:bodyPr/>
           <a:lstStyle/>
           <a:p>
-            <a:r>
-              <a:rPr lang="en-US" dirty="0"/>
-              <a:t/>
-            </a:r>
             <a:endParaRPr lang="en-US" dirty="0"/>
           </a:p>
         </p:txBody>
@@ -1835,10 +1556,6 @@
           <a:bodyPr/>
           <a:lstStyle/>
           <a:p>
-            <a:r>
-              <a:rPr lang="en-US" dirty="0"/>
-              <a:t/>
-            </a:r>
             <a:endParaRPr lang="en-US" dirty="0"/>
           </a:p>
         </p:txBody>
@@ -1912,6 +1629,11 @@
 <file path=ppt/slideMasters/slideMaster1.xml><?xml version="1.0" encoding="utf-8"?>
 <p:sldMaster xmlns:a="http://schemas.openxmlformats.org/drawingml/2006/main" xmlns:r="http://schemas.openxmlformats.org/officeDocument/2006/relationships" xmlns:p="http://schemas.openxmlformats.org/presentationml/2006/main">
   <p:cSld>
+    <p:bg>
+      <p:bgRef idx="1001">
+        <a:schemeClr val="bg1"/>
+      </p:bgRef>
+    </p:bg>
     <p:spTree>
       <p:nvGrpSpPr>
         <p:cNvPr id="1" name=""/>
@@ -2194,6 +1916,7 @@
         <a:solidFill>
           <a:srgbClr val="1B3A6B"/>
         </a:solidFill>
+        <a:effectLst/>
       </p:bgPr>
     </p:bg>
     <p:spTree>
@@ -2258,7 +1981,7 @@
         </p:nvSpPr>
         <p:spPr>
           <a:xfrm>
-            <a:off x="6949440" y="274320"/>
+            <a:off x="6766560" y="2365202"/>
             <a:ext cx="1920240" cy="502920"/>
           </a:xfrm>
           <a:prstGeom prst="rect">
@@ -2269,7 +1992,7 @@
           </a:solidFill>
           <a:ln/>
           <a:effectLst>
-            <a:outerShdw sx="100000" sy="100000" kx="0" ky="0" algn="bl" rotWithShape="0" blurRad="101600" dist="38100" dir="8100000">
+            <a:outerShdw blurRad="101600" dist="38100" dir="8100000" algn="bl" rotWithShape="0">
               <a:srgbClr val="000000">
                 <a:alpha val="18000"/>
               </a:srgbClr>
@@ -2285,7 +2008,7 @@
         </p:nvSpPr>
         <p:spPr>
           <a:xfrm>
-            <a:off x="6949440" y="274320"/>
+            <a:off x="6676172" y="2323704"/>
             <a:ext cx="1920240" cy="502920"/>
           </a:xfrm>
           <a:prstGeom prst="rect">
@@ -2298,7 +2021,7 @@
           <a:bodyPr wrap="square" lIns="0" tIns="0" rIns="0" bIns="0" rtlCol="0" anchor="ctr"/>
           <a:lstStyle/>
           <a:p>
-            <a:pPr algn="ctr" indent="0" marL="0">
+            <a:pPr marL="0" indent="0" algn="ctr">
               <a:buNone/>
             </a:pPr>
             <a:r>
@@ -2321,8 +2044,8 @@
         </p:nvSpPr>
         <p:spPr>
           <a:xfrm>
-            <a:off x="457200" y="640080"/>
-            <a:ext cx="8229600" cy="640080"/>
+            <a:off x="3263462" y="997430"/>
+            <a:ext cx="2916622" cy="640080"/>
           </a:xfrm>
           <a:prstGeom prst="rect">
             <a:avLst/>
@@ -2334,7 +2057,7 @@
           <a:bodyPr wrap="square" rtlCol="0" anchor="ctr"/>
           <a:lstStyle/>
           <a:p>
-            <a:pPr algn="l" indent="0" marL="0">
+            <a:pPr marL="0" indent="0" algn="l">
               <a:buNone/>
             </a:pPr>
             <a:r>
@@ -2357,8 +2080,8 @@
         </p:nvSpPr>
         <p:spPr>
           <a:xfrm>
-            <a:off x="457200" y="1188720"/>
-            <a:ext cx="8229600" cy="1737360"/>
+            <a:off x="1213944" y="1661987"/>
+            <a:ext cx="6088433" cy="1285336"/>
           </a:xfrm>
           <a:prstGeom prst="rect">
             <a:avLst/>
@@ -2370,7 +2093,7 @@
           <a:bodyPr wrap="square" rtlCol="0" anchor="ctr"/>
           <a:lstStyle/>
           <a:p>
-            <a:pPr algn="l" indent="0" marL="0">
+            <a:pPr marL="0" indent="0" algn="l">
               <a:buNone/>
             </a:pPr>
             <a:r>
@@ -2384,7 +2107,7 @@
             <a:endParaRPr lang="en-US" sz="4600" dirty="0"/>
           </a:p>
           <a:p>
-            <a:pPr algn="l" indent="0" marL="0">
+            <a:pPr marL="0" indent="0" algn="l">
               <a:buNone/>
             </a:pPr>
             <a:r>
@@ -2420,7 +2143,7 @@
           <a:bodyPr wrap="square" rtlCol="0" anchor="ctr"/>
           <a:lstStyle/>
           <a:p>
-            <a:pPr algn="l" indent="0" marL="0">
+            <a:pPr marL="0" indent="0" algn="l">
               <a:buNone/>
             </a:pPr>
             <a:r>
@@ -2479,7 +2202,7 @@
           <a:bodyPr wrap="square" rtlCol="0" anchor="ctr"/>
           <a:lstStyle/>
           <a:p>
-            <a:pPr indent="0" marL="0">
+            <a:pPr marL="0" indent="0">
               <a:buNone/>
             </a:pPr>
             <a:r>
@@ -2490,9 +2213,6 @@
               </a:rPr>
               <a:t>Étudiants : </a:t>
             </a:r>
-            <a:pPr indent="0" marL="0">
-              <a:buNone/>
-            </a:pPr>
             <a:r>
               <a:rPr lang="en-US" sz="1300" dirty="0">
                 <a:solidFill>
@@ -2526,7 +2246,7 @@
           <a:bodyPr wrap="square" rtlCol="0" anchor="ctr"/>
           <a:lstStyle/>
           <a:p>
-            <a:pPr indent="0" marL="0">
+            <a:pPr marL="0" indent="0">
               <a:buNone/>
             </a:pPr>
             <a:r>
@@ -2537,9 +2257,6 @@
               </a:rPr>
               <a:t>Encadrant : </a:t>
             </a:r>
-            <a:pPr indent="0" marL="0">
-              <a:buNone/>
-            </a:pPr>
             <a:r>
               <a:rPr lang="en-US" sz="1300" dirty="0">
                 <a:solidFill>
@@ -2573,7 +2290,7 @@
           <a:bodyPr wrap="square" rtlCol="0" anchor="ctr"/>
           <a:lstStyle/>
           <a:p>
-            <a:pPr algn="l" indent="0" marL="0">
+            <a:pPr marL="0" indent="0" algn="l">
               <a:buNone/>
             </a:pPr>
             <a:r>
@@ -2585,6 +2302,115 @@
               <a:t>mai 2026</a:t>
             </a:r>
             <a:endParaRPr lang="en-US" sz="1100" dirty="0"/>
+          </a:p>
+        </p:txBody>
+      </p:sp>
+      <p:pic>
+        <p:nvPicPr>
+          <p:cNvPr id="13" name="Picture 1" descr="page1image50044432">
+            <a:extLst>
+              <a:ext uri="{FF2B5EF4-FFF2-40B4-BE49-F238E27FC236}">
+                <a16:creationId xmlns:a16="http://schemas.microsoft.com/office/drawing/2014/main" id="{E7F3C2A7-204F-814C-B9F3-8234852E4FCA}"/>
+              </a:ext>
+            </a:extLst>
+          </p:cNvPr>
+          <p:cNvPicPr>
+            <a:picLocks noChangeAspect="1" noChangeArrowheads="1"/>
+          </p:cNvPicPr>
+          <p:nvPr/>
+        </p:nvPicPr>
+        <p:blipFill>
+          <a:blip r:embed="rId3">
+            <a:extLst>
+              <a:ext uri="{28A0092B-C50C-407E-A947-70E740481C1C}">
+                <a14:useLocalDpi xmlns:a14="http://schemas.microsoft.com/office/drawing/2010/main" val="0"/>
+              </a:ext>
+            </a:extLst>
+          </a:blip>
+          <a:srcRect/>
+          <a:stretch>
+            <a:fillRect/>
+          </a:stretch>
+        </p:blipFill>
+        <p:spPr bwMode="auto">
+          <a:xfrm>
+            <a:off x="332913" y="250351"/>
+            <a:ext cx="1368114" cy="1021400"/>
+          </a:xfrm>
+          <a:prstGeom prst="rect">
+            <a:avLst/>
+          </a:prstGeom>
+          <a:noFill/>
+          <a:extLst>
+            <a:ext uri="{909E8E84-426E-40DD-AFC4-6F175D3DCCD1}">
+              <a14:hiddenFill xmlns:a14="http://schemas.microsoft.com/office/drawing/2010/main">
+                <a:solidFill>
+                  <a:srgbClr val="FFFFFF"/>
+                </a:solidFill>
+              </a14:hiddenFill>
+            </a:ext>
+          </a:extLst>
+        </p:spPr>
+      </p:pic>
+      <p:sp>
+        <p:nvSpPr>
+          <p:cNvPr id="14" name="Rectangle 13">
+            <a:extLst>
+              <a:ext uri="{FF2B5EF4-FFF2-40B4-BE49-F238E27FC236}">
+                <a16:creationId xmlns:a16="http://schemas.microsoft.com/office/drawing/2014/main" id="{87FB9AC9-9D9C-994B-BE38-6297711F89EE}"/>
+              </a:ext>
+            </a:extLst>
+          </p:cNvPr>
+          <p:cNvSpPr/>
+          <p:nvPr/>
+        </p:nvSpPr>
+        <p:spPr>
+          <a:xfrm>
+            <a:off x="7442972" y="261539"/>
+            <a:ext cx="1368115" cy="1010212"/>
+          </a:xfrm>
+          <a:prstGeom prst="rect">
+            <a:avLst/>
+          </a:prstGeom>
+          <a:blipFill dpi="0" rotWithShape="1">
+            <a:blip r:embed="rId4">
+              <a:extLst>
+                <a:ext uri="{28A0092B-C50C-407E-A947-70E740481C1C}">
+                  <a14:useLocalDpi xmlns:a14="http://schemas.microsoft.com/office/drawing/2010/main" val="0"/>
+                </a:ext>
+              </a:extLst>
+            </a:blip>
+            <a:srcRect/>
+            <a:stretch>
+              <a:fillRect/>
+            </a:stretch>
+          </a:blipFill>
+          <a:ln>
+            <a:noFill/>
+          </a:ln>
+        </p:spPr>
+        <p:style>
+          <a:lnRef idx="2">
+            <a:schemeClr val="accent1">
+              <a:shade val="50000"/>
+            </a:schemeClr>
+          </a:lnRef>
+          <a:fillRef idx="1">
+            <a:schemeClr val="accent1"/>
+          </a:fillRef>
+          <a:effectRef idx="0">
+            <a:schemeClr val="accent1"/>
+          </a:effectRef>
+          <a:fontRef idx="minor">
+            <a:schemeClr val="lt1"/>
+          </a:fontRef>
+        </p:style>
+        <p:txBody>
+          <a:bodyPr rtlCol="0" anchor="ctr"/>
+          <a:lstStyle/>
+          <a:p>
+            <a:pPr algn="ctr"/>
+            <a:endParaRPr lang="fr-FR"/>
           </a:p>
         </p:txBody>
       </p:sp>
@@ -2604,6 +2430,7 @@
         <a:solidFill>
           <a:srgbClr val="FFFFFF"/>
         </a:solidFill>
+        <a:effectLst/>
       </p:bgPr>
     </p:bg>
     <p:spTree>
@@ -2661,7 +2488,7 @@
           <a:bodyPr wrap="square" lIns="0" tIns="0" rIns="0" bIns="0" rtlCol="0" anchor="ctr"/>
           <a:lstStyle/>
           <a:p>
-            <a:pPr indent="0" marL="0">
+            <a:pPr marL="0" indent="0">
               <a:buNone/>
             </a:pPr>
             <a:r>
@@ -2717,7 +2544,7 @@
           <a:bodyPr wrap="square" lIns="0" tIns="0" rIns="0" bIns="0" rtlCol="0" anchor="ctr"/>
           <a:lstStyle/>
           <a:p>
-            <a:pPr algn="ctr" indent="0" marL="0">
+            <a:pPr marL="0" indent="0" algn="ctr">
               <a:buNone/>
             </a:pPr>
             <a:r>
@@ -2751,7 +2578,7 @@
           </a:solidFill>
           <a:ln/>
           <a:effectLst>
-            <a:outerShdw sx="100000" sy="100000" kx="0" ky="0" algn="bl" rotWithShape="0" blurRad="101600" dist="38100" dir="8100000">
+            <a:outerShdw blurRad="101600" dist="38100" dir="8100000" algn="bl" rotWithShape="0">
               <a:srgbClr val="000000">
                 <a:alpha val="18000"/>
               </a:srgbClr>
@@ -2905,7 +2732,7 @@
           </a:solidFill>
           <a:ln/>
           <a:effectLst>
-            <a:outerShdw sx="100000" sy="100000" kx="0" ky="0" algn="bl" rotWithShape="0" blurRad="101600" dist="38100" dir="8100000">
+            <a:outerShdw blurRad="101600" dist="38100" dir="8100000" algn="bl" rotWithShape="0">
               <a:srgbClr val="000000">
                 <a:alpha val="18000"/>
               </a:srgbClr>
@@ -2934,7 +2761,7 @@
           <a:bodyPr wrap="square" lIns="0" tIns="0" rIns="0" bIns="0" rtlCol="0" anchor="ctr"/>
           <a:lstStyle/>
           <a:p>
-            <a:pPr algn="ctr" indent="0" marL="0">
+            <a:pPr marL="0" indent="0" algn="ctr">
               <a:buNone/>
             </a:pPr>
             <a:r>
@@ -2970,7 +2797,7 @@
           <a:bodyPr wrap="square" lIns="0" tIns="0" rIns="0" bIns="0" rtlCol="0" anchor="ctr"/>
           <a:lstStyle/>
           <a:p>
-            <a:pPr algn="ctr" indent="0" marL="0">
+            <a:pPr marL="0" indent="0" algn="ctr">
               <a:buNone/>
             </a:pPr>
             <a:r>
@@ -3004,7 +2831,7 @@
           </a:solidFill>
           <a:ln/>
           <a:effectLst>
-            <a:outerShdw sx="100000" sy="100000" kx="0" ky="0" algn="bl" rotWithShape="0" blurRad="101600" dist="38100" dir="8100000">
+            <a:outerShdw blurRad="101600" dist="38100" dir="8100000" algn="bl" rotWithShape="0">
               <a:srgbClr val="000000">
                 <a:alpha val="18000"/>
               </a:srgbClr>
@@ -3033,7 +2860,7 @@
           <a:bodyPr wrap="square" lIns="0" tIns="0" rIns="0" bIns="0" rtlCol="0" anchor="ctr"/>
           <a:lstStyle/>
           <a:p>
-            <a:pPr algn="ctr" indent="0" marL="0">
+            <a:pPr marL="0" indent="0" algn="ctr">
               <a:buNone/>
             </a:pPr>
             <a:r>
@@ -3069,7 +2896,7 @@
           <a:bodyPr wrap="square" lIns="0" tIns="0" rIns="0" bIns="0" rtlCol="0" anchor="ctr"/>
           <a:lstStyle/>
           <a:p>
-            <a:pPr algn="ctr" indent="0" marL="0">
+            <a:pPr marL="0" indent="0" algn="ctr">
               <a:buNone/>
             </a:pPr>
             <a:r>
@@ -3103,7 +2930,7 @@
           </a:solidFill>
           <a:ln/>
           <a:effectLst>
-            <a:outerShdw sx="100000" sy="100000" kx="0" ky="0" algn="bl" rotWithShape="0" blurRad="101600" dist="38100" dir="8100000">
+            <a:outerShdw blurRad="101600" dist="38100" dir="8100000" algn="bl" rotWithShape="0">
               <a:srgbClr val="000000">
                 <a:alpha val="18000"/>
               </a:srgbClr>
@@ -3132,7 +2959,7 @@
           <a:bodyPr wrap="square" lIns="0" tIns="0" rIns="0" bIns="0" rtlCol="0" anchor="ctr"/>
           <a:lstStyle/>
           <a:p>
-            <a:pPr algn="ctr" indent="0" marL="0">
+            <a:pPr marL="0" indent="0" algn="ctr">
               <a:buNone/>
             </a:pPr>
             <a:r>
@@ -3168,7 +2995,7 @@
           <a:bodyPr wrap="square" lIns="0" tIns="0" rIns="0" bIns="0" rtlCol="0" anchor="ctr"/>
           <a:lstStyle/>
           <a:p>
-            <a:pPr algn="ctr" indent="0" marL="0">
+            <a:pPr marL="0" indent="0" algn="ctr">
               <a:buNone/>
             </a:pPr>
             <a:r>
@@ -3227,7 +3054,7 @@
           <a:bodyPr wrap="square" rtlCol="0" anchor="ctr"/>
           <a:lstStyle/>
           <a:p>
-            <a:pPr indent="0" marL="0">
+            <a:pPr marL="0" indent="0">
               <a:buNone/>
             </a:pPr>
             <a:r>
@@ -3258,6 +3085,7 @@
         <a:solidFill>
           <a:srgbClr val="FFFFFF"/>
         </a:solidFill>
+        <a:effectLst/>
       </p:bgPr>
     </p:bg>
     <p:spTree>
@@ -3315,7 +3143,7 @@
           <a:bodyPr wrap="square" lIns="0" tIns="0" rIns="0" bIns="0" rtlCol="0" anchor="ctr"/>
           <a:lstStyle/>
           <a:p>
-            <a:pPr indent="0" marL="0">
+            <a:pPr marL="0" indent="0">
               <a:buNone/>
             </a:pPr>
             <a:r>
@@ -3371,7 +3199,7 @@
           <a:bodyPr wrap="square" lIns="0" tIns="0" rIns="0" bIns="0" rtlCol="0" anchor="ctr"/>
           <a:lstStyle/>
           <a:p>
-            <a:pPr algn="ctr" indent="0" marL="0">
+            <a:pPr marL="0" indent="0" algn="ctr">
               <a:buNone/>
             </a:pPr>
             <a:r>
@@ -3405,7 +3233,7 @@
           </a:solidFill>
           <a:ln/>
           <a:effectLst>
-            <a:outerShdw sx="100000" sy="100000" kx="0" ky="0" algn="bl" rotWithShape="0" blurRad="101600" dist="38100" dir="8100000">
+            <a:outerShdw blurRad="101600" dist="38100" dir="8100000" algn="bl" rotWithShape="0">
               <a:srgbClr val="000000">
                 <a:alpha val="18000"/>
               </a:srgbClr>
@@ -3559,7 +3387,7 @@
           </a:solidFill>
           <a:ln/>
           <a:effectLst>
-            <a:outerShdw sx="100000" sy="100000" kx="0" ky="0" algn="bl" rotWithShape="0" blurRad="101600" dist="38100" dir="8100000">
+            <a:outerShdw blurRad="101600" dist="38100" dir="8100000" algn="bl" rotWithShape="0">
               <a:srgbClr val="000000">
                 <a:alpha val="18000"/>
               </a:srgbClr>
@@ -3588,7 +3416,7 @@
           <a:bodyPr wrap="square" lIns="0" tIns="0" rIns="0" bIns="0" rtlCol="0" anchor="ctr"/>
           <a:lstStyle/>
           <a:p>
-            <a:pPr algn="ctr" indent="0" marL="0">
+            <a:pPr marL="0" indent="0" algn="ctr">
               <a:buNone/>
             </a:pPr>
             <a:r>
@@ -3624,7 +3452,7 @@
           <a:bodyPr wrap="square" lIns="0" tIns="0" rIns="0" bIns="0" rtlCol="0" anchor="ctr"/>
           <a:lstStyle/>
           <a:p>
-            <a:pPr algn="ctr" indent="0" marL="0">
+            <a:pPr marL="0" indent="0" algn="ctr">
               <a:buNone/>
             </a:pPr>
             <a:r>
@@ -3658,7 +3486,7 @@
           </a:solidFill>
           <a:ln/>
           <a:effectLst>
-            <a:outerShdw sx="100000" sy="100000" kx="0" ky="0" algn="bl" rotWithShape="0" blurRad="101600" dist="38100" dir="8100000">
+            <a:outerShdw blurRad="101600" dist="38100" dir="8100000" algn="bl" rotWithShape="0">
               <a:srgbClr val="000000">
                 <a:alpha val="18000"/>
               </a:srgbClr>
@@ -3687,7 +3515,7 @@
           <a:bodyPr wrap="square" lIns="0" tIns="0" rIns="0" bIns="0" rtlCol="0" anchor="ctr"/>
           <a:lstStyle/>
           <a:p>
-            <a:pPr algn="ctr" indent="0" marL="0">
+            <a:pPr marL="0" indent="0" algn="ctr">
               <a:buNone/>
             </a:pPr>
             <a:r>
@@ -3723,7 +3551,7 @@
           <a:bodyPr wrap="square" lIns="0" tIns="0" rIns="0" bIns="0" rtlCol="0" anchor="ctr"/>
           <a:lstStyle/>
           <a:p>
-            <a:pPr algn="ctr" indent="0" marL="0">
+            <a:pPr marL="0" indent="0" algn="ctr">
               <a:buNone/>
             </a:pPr>
             <a:r>
@@ -3757,7 +3585,7 @@
           </a:solidFill>
           <a:ln/>
           <a:effectLst>
-            <a:outerShdw sx="100000" sy="100000" kx="0" ky="0" algn="bl" rotWithShape="0" blurRad="101600" dist="38100" dir="8100000">
+            <a:outerShdw blurRad="101600" dist="38100" dir="8100000" algn="bl" rotWithShape="0">
               <a:srgbClr val="000000">
                 <a:alpha val="18000"/>
               </a:srgbClr>
@@ -3786,7 +3614,7 @@
           <a:bodyPr wrap="square" lIns="0" tIns="0" rIns="0" bIns="0" rtlCol="0" anchor="ctr"/>
           <a:lstStyle/>
           <a:p>
-            <a:pPr algn="ctr" indent="0" marL="0">
+            <a:pPr marL="0" indent="0" algn="ctr">
               <a:buNone/>
             </a:pPr>
             <a:r>
@@ -3822,7 +3650,7 @@
           <a:bodyPr wrap="square" lIns="0" tIns="0" rIns="0" bIns="0" rtlCol="0" anchor="ctr"/>
           <a:lstStyle/>
           <a:p>
-            <a:pPr algn="ctr" indent="0" marL="0">
+            <a:pPr marL="0" indent="0" algn="ctr">
               <a:buNone/>
             </a:pPr>
             <a:r>
@@ -3881,7 +3709,7 @@
           <a:bodyPr wrap="square" rtlCol="0" anchor="ctr"/>
           <a:lstStyle/>
           <a:p>
-            <a:pPr indent="0" marL="0">
+            <a:pPr marL="0" indent="0">
               <a:buNone/>
             </a:pPr>
             <a:r>
@@ -3912,6 +3740,7 @@
         <a:solidFill>
           <a:srgbClr val="FFFFFF"/>
         </a:solidFill>
+        <a:effectLst/>
       </p:bgPr>
     </p:bg>
     <p:spTree>
@@ -3969,7 +3798,7 @@
           <a:bodyPr wrap="square" lIns="0" tIns="0" rIns="0" bIns="0" rtlCol="0" anchor="ctr"/>
           <a:lstStyle/>
           <a:p>
-            <a:pPr indent="0" marL="0">
+            <a:pPr marL="0" indent="0">
               <a:buNone/>
             </a:pPr>
             <a:r>
@@ -4025,7 +3854,7 @@
           <a:bodyPr wrap="square" lIns="0" tIns="0" rIns="0" bIns="0" rtlCol="0" anchor="ctr"/>
           <a:lstStyle/>
           <a:p>
-            <a:pPr algn="ctr" indent="0" marL="0">
+            <a:pPr marL="0" indent="0" algn="ctr">
               <a:buNone/>
             </a:pPr>
             <a:r>
@@ -4059,7 +3888,7 @@
           </a:solidFill>
           <a:ln/>
           <a:effectLst>
-            <a:outerShdw sx="100000" sy="100000" kx="0" ky="0" algn="bl" rotWithShape="0" blurRad="101600" dist="38100" dir="8100000">
+            <a:outerShdw blurRad="101600" dist="38100" dir="8100000" algn="bl" rotWithShape="0">
               <a:srgbClr val="000000">
                 <a:alpha val="18000"/>
               </a:srgbClr>
@@ -4213,7 +4042,7 @@
           </a:solidFill>
           <a:ln/>
           <a:effectLst>
-            <a:outerShdw sx="100000" sy="100000" kx="0" ky="0" algn="bl" rotWithShape="0" blurRad="101600" dist="38100" dir="8100000">
+            <a:outerShdw blurRad="101600" dist="38100" dir="8100000" algn="bl" rotWithShape="0">
               <a:srgbClr val="000000">
                 <a:alpha val="18000"/>
               </a:srgbClr>
@@ -4242,7 +4071,7 @@
           <a:bodyPr wrap="square" lIns="0" tIns="0" rIns="0" bIns="0" rtlCol="0" anchor="ctr"/>
           <a:lstStyle/>
           <a:p>
-            <a:pPr algn="ctr" indent="0" marL="0">
+            <a:pPr marL="0" indent="0" algn="ctr">
               <a:buNone/>
             </a:pPr>
             <a:r>
@@ -4278,7 +4107,7 @@
           <a:bodyPr wrap="square" lIns="0" tIns="0" rIns="0" bIns="0" rtlCol="0" anchor="ctr"/>
           <a:lstStyle/>
           <a:p>
-            <a:pPr algn="ctr" indent="0" marL="0">
+            <a:pPr marL="0" indent="0" algn="ctr">
               <a:buNone/>
             </a:pPr>
             <a:r>
@@ -4312,7 +4141,7 @@
           </a:solidFill>
           <a:ln/>
           <a:effectLst>
-            <a:outerShdw sx="100000" sy="100000" kx="0" ky="0" algn="bl" rotWithShape="0" blurRad="101600" dist="38100" dir="8100000">
+            <a:outerShdw blurRad="101600" dist="38100" dir="8100000" algn="bl" rotWithShape="0">
               <a:srgbClr val="000000">
                 <a:alpha val="18000"/>
               </a:srgbClr>
@@ -4341,7 +4170,7 @@
           <a:bodyPr wrap="square" lIns="0" tIns="0" rIns="0" bIns="0" rtlCol="0" anchor="ctr"/>
           <a:lstStyle/>
           <a:p>
-            <a:pPr algn="ctr" indent="0" marL="0">
+            <a:pPr marL="0" indent="0" algn="ctr">
               <a:buNone/>
             </a:pPr>
             <a:r>
@@ -4377,7 +4206,7 @@
           <a:bodyPr wrap="square" lIns="0" tIns="0" rIns="0" bIns="0" rtlCol="0" anchor="ctr"/>
           <a:lstStyle/>
           <a:p>
-            <a:pPr algn="ctr" indent="0" marL="0">
+            <a:pPr marL="0" indent="0" algn="ctr">
               <a:buNone/>
             </a:pPr>
             <a:r>
@@ -4411,7 +4240,7 @@
           </a:solidFill>
           <a:ln/>
           <a:effectLst>
-            <a:outerShdw sx="100000" sy="100000" kx="0" ky="0" algn="bl" rotWithShape="0" blurRad="101600" dist="38100" dir="8100000">
+            <a:outerShdw blurRad="101600" dist="38100" dir="8100000" algn="bl" rotWithShape="0">
               <a:srgbClr val="000000">
                 <a:alpha val="18000"/>
               </a:srgbClr>
@@ -4440,7 +4269,7 @@
           <a:bodyPr wrap="square" lIns="0" tIns="0" rIns="0" bIns="0" rtlCol="0" anchor="ctr"/>
           <a:lstStyle/>
           <a:p>
-            <a:pPr algn="ctr" indent="0" marL="0">
+            <a:pPr marL="0" indent="0" algn="ctr">
               <a:buNone/>
             </a:pPr>
             <a:r>
@@ -4476,7 +4305,7 @@
           <a:bodyPr wrap="square" lIns="0" tIns="0" rIns="0" bIns="0" rtlCol="0" anchor="ctr"/>
           <a:lstStyle/>
           <a:p>
-            <a:pPr algn="ctr" indent="0" marL="0">
+            <a:pPr marL="0" indent="0" algn="ctr">
               <a:buNone/>
             </a:pPr>
             <a:r>
@@ -4535,7 +4364,7 @@
           <a:bodyPr wrap="square" rtlCol="0" anchor="ctr"/>
           <a:lstStyle/>
           <a:p>
-            <a:pPr indent="0" marL="0">
+            <a:pPr marL="0" indent="0">
               <a:buNone/>
             </a:pPr>
             <a:r>
@@ -4566,6 +4395,7 @@
         <a:solidFill>
           <a:srgbClr val="1B3A6B"/>
         </a:solidFill>
+        <a:effectLst/>
       </p:bgPr>
     </p:bg>
     <p:spTree>
@@ -4643,7 +4473,7 @@
           <a:bodyPr wrap="square" rtlCol="0" anchor="ctr"/>
           <a:lstStyle/>
           <a:p>
-            <a:pPr algn="ctr" indent="0" marL="0">
+            <a:pPr marL="0" indent="0" algn="ctr">
               <a:buNone/>
             </a:pPr>
             <a:r>
@@ -4681,7 +4511,7 @@
           <a:bodyPr wrap="square" rtlCol="0" anchor="ctr"/>
           <a:lstStyle/>
           <a:p>
-            <a:pPr algn="ctr" indent="0" marL="0">
+            <a:pPr marL="0" indent="0" algn="ctr">
               <a:buNone/>
             </a:pPr>
             <a:r>
@@ -4712,6 +4542,7 @@
         <a:solidFill>
           <a:srgbClr val="FFFFFF"/>
         </a:solidFill>
+        <a:effectLst/>
       </p:bgPr>
     </p:bg>
     <p:spTree>
@@ -4769,7 +4600,7 @@
           <a:bodyPr wrap="square" lIns="0" tIns="0" rIns="0" bIns="0" rtlCol="0" anchor="ctr"/>
           <a:lstStyle/>
           <a:p>
-            <a:pPr indent="0" marL="0">
+            <a:pPr marL="0" indent="0">
               <a:buNone/>
             </a:pPr>
             <a:r>
@@ -4825,7 +4656,7 @@
           <a:bodyPr wrap="square" lIns="0" tIns="0" rIns="0" bIns="0" rtlCol="0" anchor="ctr"/>
           <a:lstStyle/>
           <a:p>
-            <a:pPr algn="ctr" indent="0" marL="0">
+            <a:pPr marL="0" indent="0" algn="ctr">
               <a:buNone/>
             </a:pPr>
             <a:r>
@@ -4863,10 +4694,34 @@
             <a:tbl>
               <a:tblPr/>
               <a:tblGrid>
-                <a:gridCol w="1645920"/>
-                <a:gridCol w="2194560"/>
-                <a:gridCol w="2194560"/>
-                <a:gridCol w="2560320"/>
+                <a:gridCol w="1645920">
+                  <a:extLst>
+                    <a:ext uri="{9D8B030D-6E8A-4147-A177-3AD203B41FA5}">
+                      <a16:colId xmlns:a16="http://schemas.microsoft.com/office/drawing/2014/main" val="20000"/>
+                    </a:ext>
+                  </a:extLst>
+                </a:gridCol>
+                <a:gridCol w="2194560">
+                  <a:extLst>
+                    <a:ext uri="{9D8B030D-6E8A-4147-A177-3AD203B41FA5}">
+                      <a16:colId xmlns:a16="http://schemas.microsoft.com/office/drawing/2014/main" val="20001"/>
+                    </a:ext>
+                  </a:extLst>
+                </a:gridCol>
+                <a:gridCol w="2194560">
+                  <a:extLst>
+                    <a:ext uri="{9D8B030D-6E8A-4147-A177-3AD203B41FA5}">
+                      <a16:colId xmlns:a16="http://schemas.microsoft.com/office/drawing/2014/main" val="20002"/>
+                    </a:ext>
+                  </a:extLst>
+                </a:gridCol>
+                <a:gridCol w="2560320">
+                  <a:extLst>
+                    <a:ext uri="{9D8B030D-6E8A-4147-A177-3AD203B41FA5}">
+                      <a16:colId xmlns:a16="http://schemas.microsoft.com/office/drawing/2014/main" val="20003"/>
+                    </a:ext>
+                  </a:extLst>
+                </a:gridCol>
               </a:tblGrid>
               <a:tr h="0">
                 <a:tc>
@@ -4874,7 +4729,7 @@
                     <a:bodyPr/>
                     <a:lstStyle/>
                     <a:p>
-                      <a:pPr algn="ctr" indent="0" marL="0">
+                      <a:pPr marL="0" indent="0" algn="ctr">
                         <a:buNone/>
                       </a:pPr>
                       <a:r>
@@ -4888,7 +4743,7 @@
                       <a:endParaRPr lang="en-US" sz="1200" dirty="0"/>
                     </a:p>
                   </a:txBody>
-                  <a:tcPr marL="91440" marR="91440" marT="45720" marB="45720">
+                  <a:tcPr>
                     <a:lnL w="6350" cap="flat" cmpd="sng" algn="ctr">
                       <a:solidFill>
                         <a:srgbClr val="CCCCCC"/>
@@ -4935,7 +4790,7 @@
                     <a:bodyPr/>
                     <a:lstStyle/>
                     <a:p>
-                      <a:pPr algn="ctr" indent="0" marL="0">
+                      <a:pPr marL="0" indent="0" algn="ctr">
                         <a:buNone/>
                       </a:pPr>
                       <a:r>
@@ -4949,7 +4804,7 @@
                       <a:endParaRPr lang="en-US" sz="1200" dirty="0"/>
                     </a:p>
                   </a:txBody>
-                  <a:tcPr marL="91440" marR="91440" marT="45720" marB="45720">
+                  <a:tcPr>
                     <a:lnL w="6350" cap="flat" cmpd="sng" algn="ctr">
                       <a:solidFill>
                         <a:srgbClr val="CCCCCC"/>
@@ -4996,7 +4851,7 @@
                     <a:bodyPr/>
                     <a:lstStyle/>
                     <a:p>
-                      <a:pPr algn="ctr" indent="0" marL="0">
+                      <a:pPr marL="0" indent="0" algn="ctr">
                         <a:buNone/>
                       </a:pPr>
                       <a:r>
@@ -5010,7 +4865,7 @@
                       <a:endParaRPr lang="en-US" sz="1200" dirty="0"/>
                     </a:p>
                   </a:txBody>
-                  <a:tcPr marL="91440" marR="91440" marT="45720" marB="45720">
+                  <a:tcPr>
                     <a:lnL w="6350" cap="flat" cmpd="sng" algn="ctr">
                       <a:solidFill>
                         <a:srgbClr val="CCCCCC"/>
@@ -5057,7 +4912,7 @@
                     <a:bodyPr/>
                     <a:lstStyle/>
                     <a:p>
-                      <a:pPr algn="ctr" indent="0" marL="0">
+                      <a:pPr marL="0" indent="0" algn="ctr">
                         <a:buNone/>
                       </a:pPr>
                       <a:r>
@@ -5071,7 +4926,7 @@
                       <a:endParaRPr lang="en-US" sz="1200" dirty="0"/>
                     </a:p>
                   </a:txBody>
-                  <a:tcPr marL="91440" marR="91440" marT="45720" marB="45720">
+                  <a:tcPr>
                     <a:lnL w="6350" cap="flat" cmpd="sng" algn="ctr">
                       <a:solidFill>
                         <a:srgbClr val="CCCCCC"/>
@@ -5113,6 +4968,11 @@
                     </a:solidFill>
                   </a:tcPr>
                 </a:tc>
+                <a:extLst>
+                  <a:ext uri="{0D108BD9-81ED-4DB2-BD59-A6C34878D82A}">
+                    <a16:rowId xmlns:a16="http://schemas.microsoft.com/office/drawing/2014/main" val="10000"/>
+                  </a:ext>
+                </a:extLst>
               </a:tr>
               <a:tr h="0">
                 <a:tc>
@@ -5120,7 +4980,7 @@
                     <a:bodyPr/>
                     <a:lstStyle/>
                     <a:p>
-                      <a:pPr algn="ctr" indent="0" marL="0">
+                      <a:pPr marL="0" indent="0" algn="ctr">
                         <a:buNone/>
                       </a:pPr>
                       <a:r>
@@ -5134,7 +4994,7 @@
                       <a:endParaRPr lang="en-US" sz="1100" dirty="0"/>
                     </a:p>
                   </a:txBody>
-                  <a:tcPr marL="91440" marR="91440" marT="45720" marB="45720">
+                  <a:tcPr>
                     <a:lnL w="6350" cap="flat" cmpd="sng" algn="ctr">
                       <a:solidFill>
                         <a:srgbClr val="CCCCCC"/>
@@ -5178,7 +5038,7 @@
                     <a:bodyPr/>
                     <a:lstStyle/>
                     <a:p>
-                      <a:pPr algn="ctr" indent="0" marL="0">
+                      <a:pPr marL="0" indent="0" algn="ctr">
                         <a:buNone/>
                       </a:pPr>
                       <a:r>
@@ -5192,7 +5052,7 @@
                       <a:endParaRPr lang="en-US" sz="1100" dirty="0"/>
                     </a:p>
                   </a:txBody>
-                  <a:tcPr marL="91440" marR="91440" marT="45720" marB="45720">
+                  <a:tcPr>
                     <a:lnL w="6350" cap="flat" cmpd="sng" algn="ctr">
                       <a:solidFill>
                         <a:srgbClr val="CCCCCC"/>
@@ -5236,7 +5096,7 @@
                     <a:bodyPr/>
                     <a:lstStyle/>
                     <a:p>
-                      <a:pPr algn="ctr" indent="0" marL="0">
+                      <a:pPr marL="0" indent="0" algn="ctr">
                         <a:buNone/>
                       </a:pPr>
                       <a:r>
@@ -5250,7 +5110,7 @@
                       <a:endParaRPr lang="en-US" sz="1100" dirty="0"/>
                     </a:p>
                   </a:txBody>
-                  <a:tcPr marL="91440" marR="91440" marT="45720" marB="45720">
+                  <a:tcPr>
                     <a:lnL w="6350" cap="flat" cmpd="sng" algn="ctr">
                       <a:solidFill>
                         <a:srgbClr val="CCCCCC"/>
@@ -5294,7 +5154,7 @@
                     <a:bodyPr/>
                     <a:lstStyle/>
                     <a:p>
-                      <a:pPr algn="ctr" indent="0" marL="0">
+                      <a:pPr marL="0" indent="0" algn="ctr">
                         <a:buNone/>
                       </a:pPr>
                       <a:r>
@@ -5308,7 +5168,7 @@
                       <a:endParaRPr lang="en-US" sz="1100" dirty="0"/>
                     </a:p>
                   </a:txBody>
-                  <a:tcPr marL="91440" marR="91440" marT="45720" marB="45720">
+                  <a:tcPr>
                     <a:lnL w="6350" cap="flat" cmpd="sng" algn="ctr">
                       <a:solidFill>
                         <a:srgbClr val="CCCCCC"/>
@@ -5347,6 +5207,11 @@
                     </a:lnB>
                   </a:tcPr>
                 </a:tc>
+                <a:extLst>
+                  <a:ext uri="{0D108BD9-81ED-4DB2-BD59-A6C34878D82A}">
+                    <a16:rowId xmlns:a16="http://schemas.microsoft.com/office/drawing/2014/main" val="10001"/>
+                  </a:ext>
+                </a:extLst>
               </a:tr>
               <a:tr h="0">
                 <a:tc>
@@ -5354,7 +5219,7 @@
                     <a:bodyPr/>
                     <a:lstStyle/>
                     <a:p>
-                      <a:pPr algn="ctr" indent="0" marL="0">
+                      <a:pPr marL="0" indent="0" algn="ctr">
                         <a:buNone/>
                       </a:pPr>
                       <a:r>
@@ -5368,7 +5233,7 @@
                       <a:endParaRPr lang="en-US" sz="1100" dirty="0"/>
                     </a:p>
                   </a:txBody>
-                  <a:tcPr marL="91440" marR="91440" marT="45720" marB="45720">
+                  <a:tcPr>
                     <a:lnL w="6350" cap="flat" cmpd="sng" algn="ctr">
                       <a:solidFill>
                         <a:srgbClr val="CCCCCC"/>
@@ -5412,7 +5277,7 @@
                     <a:bodyPr/>
                     <a:lstStyle/>
                     <a:p>
-                      <a:pPr algn="ctr" indent="0" marL="0">
+                      <a:pPr marL="0" indent="0" algn="ctr">
                         <a:buNone/>
                       </a:pPr>
                       <a:r>
@@ -5426,7 +5291,7 @@
                       <a:endParaRPr lang="en-US" sz="1100" dirty="0"/>
                     </a:p>
                   </a:txBody>
-                  <a:tcPr marL="91440" marR="91440" marT="45720" marB="45720">
+                  <a:tcPr>
                     <a:lnL w="6350" cap="flat" cmpd="sng" algn="ctr">
                       <a:solidFill>
                         <a:srgbClr val="CCCCCC"/>
@@ -5470,7 +5335,7 @@
                     <a:bodyPr/>
                     <a:lstStyle/>
                     <a:p>
-                      <a:pPr algn="ctr" indent="0" marL="0">
+                      <a:pPr marL="0" indent="0" algn="ctr">
                         <a:buNone/>
                       </a:pPr>
                       <a:r>
@@ -5484,7 +5349,7 @@
                       <a:endParaRPr lang="en-US" sz="1100" dirty="0"/>
                     </a:p>
                   </a:txBody>
-                  <a:tcPr marL="91440" marR="91440" marT="45720" marB="45720">
+                  <a:tcPr>
                     <a:lnL w="6350" cap="flat" cmpd="sng" algn="ctr">
                       <a:solidFill>
                         <a:srgbClr val="CCCCCC"/>
@@ -5528,7 +5393,7 @@
                     <a:bodyPr/>
                     <a:lstStyle/>
                     <a:p>
-                      <a:pPr algn="ctr" indent="0" marL="0">
+                      <a:pPr marL="0" indent="0" algn="ctr">
                         <a:buNone/>
                       </a:pPr>
                       <a:r>
@@ -5542,7 +5407,7 @@
                       <a:endParaRPr lang="en-US" sz="1100" dirty="0"/>
                     </a:p>
                   </a:txBody>
-                  <a:tcPr marL="91440" marR="91440" marT="45720" marB="45720">
+                  <a:tcPr>
                     <a:lnL w="6350" cap="flat" cmpd="sng" algn="ctr">
                       <a:solidFill>
                         <a:srgbClr val="CCCCCC"/>
@@ -5581,6 +5446,11 @@
                     </a:lnB>
                   </a:tcPr>
                 </a:tc>
+                <a:extLst>
+                  <a:ext uri="{0D108BD9-81ED-4DB2-BD59-A6C34878D82A}">
+                    <a16:rowId xmlns:a16="http://schemas.microsoft.com/office/drawing/2014/main" val="10002"/>
+                  </a:ext>
+                </a:extLst>
               </a:tr>
               <a:tr h="0">
                 <a:tc>
@@ -5588,7 +5458,7 @@
                     <a:bodyPr/>
                     <a:lstStyle/>
                     <a:p>
-                      <a:pPr algn="ctr" indent="0" marL="0">
+                      <a:pPr marL="0" indent="0" algn="ctr">
                         <a:buNone/>
                       </a:pPr>
                       <a:r>
@@ -5602,7 +5472,7 @@
                       <a:endParaRPr lang="en-US" sz="1100" dirty="0"/>
                     </a:p>
                   </a:txBody>
-                  <a:tcPr marL="91440" marR="91440" marT="45720" marB="45720">
+                  <a:tcPr>
                     <a:lnL w="6350" cap="flat" cmpd="sng" algn="ctr">
                       <a:solidFill>
                         <a:srgbClr val="CCCCCC"/>
@@ -5646,7 +5516,7 @@
                     <a:bodyPr/>
                     <a:lstStyle/>
                     <a:p>
-                      <a:pPr algn="ctr" indent="0" marL="0">
+                      <a:pPr marL="0" indent="0" algn="ctr">
                         <a:buNone/>
                       </a:pPr>
                       <a:r>
@@ -5660,7 +5530,7 @@
                       <a:endParaRPr lang="en-US" sz="1100" dirty="0"/>
                     </a:p>
                   </a:txBody>
-                  <a:tcPr marL="91440" marR="91440" marT="45720" marB="45720">
+                  <a:tcPr>
                     <a:lnL w="6350" cap="flat" cmpd="sng" algn="ctr">
                       <a:solidFill>
                         <a:srgbClr val="CCCCCC"/>
@@ -5704,7 +5574,7 @@
                     <a:bodyPr/>
                     <a:lstStyle/>
                     <a:p>
-                      <a:pPr algn="ctr" indent="0" marL="0">
+                      <a:pPr marL="0" indent="0" algn="ctr">
                         <a:buNone/>
                       </a:pPr>
                       <a:r>
@@ -5718,7 +5588,7 @@
                       <a:endParaRPr lang="en-US" sz="1100" dirty="0"/>
                     </a:p>
                   </a:txBody>
-                  <a:tcPr marL="91440" marR="91440" marT="45720" marB="45720">
+                  <a:tcPr>
                     <a:lnL w="6350" cap="flat" cmpd="sng" algn="ctr">
                       <a:solidFill>
                         <a:srgbClr val="CCCCCC"/>
@@ -5762,7 +5632,7 @@
                     <a:bodyPr/>
                     <a:lstStyle/>
                     <a:p>
-                      <a:pPr algn="ctr" indent="0" marL="0">
+                      <a:pPr marL="0" indent="0" algn="ctr">
                         <a:buNone/>
                       </a:pPr>
                       <a:r>
@@ -5776,7 +5646,7 @@
                       <a:endParaRPr lang="en-US" sz="1100" dirty="0"/>
                     </a:p>
                   </a:txBody>
-                  <a:tcPr marL="91440" marR="91440" marT="45720" marB="45720">
+                  <a:tcPr>
                     <a:lnL w="6350" cap="flat" cmpd="sng" algn="ctr">
                       <a:solidFill>
                         <a:srgbClr val="CCCCCC"/>
@@ -5815,6 +5685,11 @@
                     </a:lnB>
                   </a:tcPr>
                 </a:tc>
+                <a:extLst>
+                  <a:ext uri="{0D108BD9-81ED-4DB2-BD59-A6C34878D82A}">
+                    <a16:rowId xmlns:a16="http://schemas.microsoft.com/office/drawing/2014/main" val="10003"/>
+                  </a:ext>
+                </a:extLst>
               </a:tr>
               <a:tr h="0">
                 <a:tc>
@@ -5822,7 +5697,7 @@
                     <a:bodyPr/>
                     <a:lstStyle/>
                     <a:p>
-                      <a:pPr algn="ctr" indent="0" marL="0">
+                      <a:pPr marL="0" indent="0" algn="ctr">
                         <a:buNone/>
                       </a:pPr>
                       <a:r>
@@ -5836,7 +5711,7 @@
                       <a:endParaRPr lang="en-US" sz="1100" dirty="0"/>
                     </a:p>
                   </a:txBody>
-                  <a:tcPr marL="91440" marR="91440" marT="45720" marB="45720">
+                  <a:tcPr>
                     <a:lnL w="6350" cap="flat" cmpd="sng" algn="ctr">
                       <a:solidFill>
                         <a:srgbClr val="CCCCCC"/>
@@ -5880,7 +5755,7 @@
                     <a:bodyPr/>
                     <a:lstStyle/>
                     <a:p>
-                      <a:pPr algn="ctr" indent="0" marL="0">
+                      <a:pPr marL="0" indent="0" algn="ctr">
                         <a:buNone/>
                       </a:pPr>
                       <a:r>
@@ -5894,7 +5769,7 @@
                       <a:endParaRPr lang="en-US" sz="1100" dirty="0"/>
                     </a:p>
                   </a:txBody>
-                  <a:tcPr marL="91440" marR="91440" marT="45720" marB="45720">
+                  <a:tcPr>
                     <a:lnL w="6350" cap="flat" cmpd="sng" algn="ctr">
                       <a:solidFill>
                         <a:srgbClr val="CCCCCC"/>
@@ -5938,7 +5813,7 @@
                     <a:bodyPr/>
                     <a:lstStyle/>
                     <a:p>
-                      <a:pPr algn="ctr" indent="0" marL="0">
+                      <a:pPr marL="0" indent="0" algn="ctr">
                         <a:buNone/>
                       </a:pPr>
                       <a:r>
@@ -5952,7 +5827,7 @@
                       <a:endParaRPr lang="en-US" sz="1100" dirty="0"/>
                     </a:p>
                   </a:txBody>
-                  <a:tcPr marL="91440" marR="91440" marT="45720" marB="45720">
+                  <a:tcPr>
                     <a:lnL w="6350" cap="flat" cmpd="sng" algn="ctr">
                       <a:solidFill>
                         <a:srgbClr val="CCCCCC"/>
@@ -5996,7 +5871,7 @@
                     <a:bodyPr/>
                     <a:lstStyle/>
                     <a:p>
-                      <a:pPr algn="ctr" indent="0" marL="0">
+                      <a:pPr marL="0" indent="0" algn="ctr">
                         <a:buNone/>
                       </a:pPr>
                       <a:r>
@@ -6010,7 +5885,7 @@
                       <a:endParaRPr lang="en-US" sz="1100" dirty="0"/>
                     </a:p>
                   </a:txBody>
-                  <a:tcPr marL="91440" marR="91440" marT="45720" marB="45720">
+                  <a:tcPr>
                     <a:lnL w="6350" cap="flat" cmpd="sng" algn="ctr">
                       <a:solidFill>
                         <a:srgbClr val="CCCCCC"/>
@@ -6049,6 +5924,11 @@
                     </a:lnB>
                   </a:tcPr>
                 </a:tc>
+                <a:extLst>
+                  <a:ext uri="{0D108BD9-81ED-4DB2-BD59-A6C34878D82A}">
+                    <a16:rowId xmlns:a16="http://schemas.microsoft.com/office/drawing/2014/main" val="10004"/>
+                  </a:ext>
+                </a:extLst>
               </a:tr>
               <a:tr h="0">
                 <a:tc>
@@ -6056,7 +5936,7 @@
                     <a:bodyPr/>
                     <a:lstStyle/>
                     <a:p>
-                      <a:pPr algn="ctr" indent="0" marL="0">
+                      <a:pPr marL="0" indent="0" algn="ctr">
                         <a:buNone/>
                       </a:pPr>
                       <a:r>
@@ -6070,7 +5950,7 @@
                       <a:endParaRPr lang="en-US" sz="1100" dirty="0"/>
                     </a:p>
                   </a:txBody>
-                  <a:tcPr marL="91440" marR="91440" marT="45720" marB="45720">
+                  <a:tcPr>
                     <a:lnL w="6350" cap="flat" cmpd="sng" algn="ctr">
                       <a:solidFill>
                         <a:srgbClr val="CCCCCC"/>
@@ -6114,7 +5994,7 @@
                     <a:bodyPr/>
                     <a:lstStyle/>
                     <a:p>
-                      <a:pPr algn="ctr" indent="0" marL="0">
+                      <a:pPr marL="0" indent="0" algn="ctr">
                         <a:buNone/>
                       </a:pPr>
                       <a:r>
@@ -6128,7 +6008,7 @@
                       <a:endParaRPr lang="en-US" sz="1100" dirty="0"/>
                     </a:p>
                   </a:txBody>
-                  <a:tcPr marL="91440" marR="91440" marT="45720" marB="45720">
+                  <a:tcPr>
                     <a:lnL w="6350" cap="flat" cmpd="sng" algn="ctr">
                       <a:solidFill>
                         <a:srgbClr val="CCCCCC"/>
@@ -6172,7 +6052,7 @@
                     <a:bodyPr/>
                     <a:lstStyle/>
                     <a:p>
-                      <a:pPr algn="ctr" indent="0" marL="0">
+                      <a:pPr marL="0" indent="0" algn="ctr">
                         <a:buNone/>
                       </a:pPr>
                       <a:r>
@@ -6186,7 +6066,7 @@
                       <a:endParaRPr lang="en-US" sz="1100" dirty="0"/>
                     </a:p>
                   </a:txBody>
-                  <a:tcPr marL="91440" marR="91440" marT="45720" marB="45720">
+                  <a:tcPr>
                     <a:lnL w="6350" cap="flat" cmpd="sng" algn="ctr">
                       <a:solidFill>
                         <a:srgbClr val="CCCCCC"/>
@@ -6230,7 +6110,7 @@
                     <a:bodyPr/>
                     <a:lstStyle/>
                     <a:p>
-                      <a:pPr algn="ctr" indent="0" marL="0">
+                      <a:pPr marL="0" indent="0" algn="ctr">
                         <a:buNone/>
                       </a:pPr>
                       <a:r>
@@ -6244,7 +6124,7 @@
                       <a:endParaRPr lang="en-US" sz="1100" dirty="0"/>
                     </a:p>
                   </a:txBody>
-                  <a:tcPr marL="91440" marR="91440" marT="45720" marB="45720">
+                  <a:tcPr>
                     <a:lnL w="6350" cap="flat" cmpd="sng" algn="ctr">
                       <a:solidFill>
                         <a:srgbClr val="CCCCCC"/>
@@ -6283,6 +6163,11 @@
                     </a:lnB>
                   </a:tcPr>
                 </a:tc>
+                <a:extLst>
+                  <a:ext uri="{0D108BD9-81ED-4DB2-BD59-A6C34878D82A}">
+                    <a16:rowId xmlns:a16="http://schemas.microsoft.com/office/drawing/2014/main" val="10005"/>
+                  </a:ext>
+                </a:extLst>
               </a:tr>
             </a:tbl>
           </a:graphicData>
@@ -6332,7 +6217,7 @@
           <a:bodyPr wrap="square" rtlCol="0" anchor="ctr"/>
           <a:lstStyle/>
           <a:p>
-            <a:pPr algn="l" indent="0" marL="0">
+            <a:pPr marL="0" indent="0" algn="l">
               <a:buNone/>
             </a:pPr>
             <a:r>
@@ -6363,6 +6248,7 @@
         <a:solidFill>
           <a:srgbClr val="1B3A6B"/>
         </a:solidFill>
+        <a:effectLst/>
       </p:bgPr>
     </p:bg>
     <p:spTree>
@@ -6440,7 +6326,7 @@
           <a:bodyPr wrap="square" rtlCol="0" anchor="ctr"/>
           <a:lstStyle/>
           <a:p>
-            <a:pPr algn="ctr" indent="0" marL="0">
+            <a:pPr marL="0" indent="0" algn="ctr">
               <a:buNone/>
             </a:pPr>
             <a:r>
@@ -6478,7 +6364,7 @@
           <a:bodyPr wrap="square" rtlCol="0" anchor="ctr"/>
           <a:lstStyle/>
           <a:p>
-            <a:pPr algn="ctr" indent="0" marL="0">
+            <a:pPr marL="0" indent="0" algn="ctr">
               <a:buNone/>
             </a:pPr>
             <a:r>
@@ -6509,6 +6395,7 @@
         <a:solidFill>
           <a:srgbClr val="1B3A6B"/>
         </a:solidFill>
+        <a:effectLst/>
       </p:bgPr>
     </p:bg>
     <p:spTree>
@@ -6566,7 +6453,7 @@
           <a:bodyPr wrap="square" rtlCol="0" anchor="ctr"/>
           <a:lstStyle/>
           <a:p>
-            <a:pPr indent="0" marL="0">
+            <a:pPr marL="0" indent="0">
               <a:buNone/>
             </a:pPr>
             <a:r>
@@ -6602,7 +6489,7 @@
           </a:solidFill>
           <a:ln/>
           <a:effectLst>
-            <a:outerShdw sx="100000" sy="100000" kx="0" ky="0" algn="bl" rotWithShape="0" blurRad="101600" dist="38100" dir="8100000">
+            <a:outerShdw blurRad="101600" dist="38100" dir="8100000" algn="bl" rotWithShape="0">
               <a:srgbClr val="000000">
                 <a:alpha val="18000"/>
               </a:srgbClr>
@@ -6651,7 +6538,7 @@
           <a:bodyPr wrap="square" rtlCol="0" anchor="ctr"/>
           <a:lstStyle/>
           <a:p>
-            <a:pPr indent="0" marL="0">
+            <a:pPr marL="0" indent="0">
               <a:buNone/>
             </a:pPr>
             <a:r>
@@ -6687,7 +6574,7 @@
           <a:bodyPr wrap="square" rtlCol="0" anchor="ctr"/>
           <a:lstStyle/>
           <a:p>
-            <a:pPr indent="0" marL="0">
+            <a:pPr marL="0" indent="0">
               <a:buNone/>
             </a:pPr>
             <a:r>
@@ -6723,7 +6610,7 @@
           </a:solidFill>
           <a:ln/>
           <a:effectLst>
-            <a:outerShdw sx="100000" sy="100000" kx="0" ky="0" algn="bl" rotWithShape="0" blurRad="101600" dist="38100" dir="8100000">
+            <a:outerShdw blurRad="101600" dist="38100" dir="8100000" algn="bl" rotWithShape="0">
               <a:srgbClr val="000000">
                 <a:alpha val="18000"/>
               </a:srgbClr>
@@ -6772,7 +6659,7 @@
           <a:bodyPr wrap="square" rtlCol="0" anchor="ctr"/>
           <a:lstStyle/>
           <a:p>
-            <a:pPr indent="0" marL="0">
+            <a:pPr marL="0" indent="0">
               <a:buNone/>
             </a:pPr>
             <a:r>
@@ -6808,7 +6695,7 @@
           <a:bodyPr wrap="square" rtlCol="0" anchor="ctr"/>
           <a:lstStyle/>
           <a:p>
-            <a:pPr indent="0" marL="0">
+            <a:pPr marL="0" indent="0">
               <a:buNone/>
             </a:pPr>
             <a:r>
@@ -6844,7 +6731,7 @@
           </a:solidFill>
           <a:ln/>
           <a:effectLst>
-            <a:outerShdw sx="100000" sy="100000" kx="0" ky="0" algn="bl" rotWithShape="0" blurRad="101600" dist="38100" dir="8100000">
+            <a:outerShdw blurRad="101600" dist="38100" dir="8100000" algn="bl" rotWithShape="0">
               <a:srgbClr val="000000">
                 <a:alpha val="18000"/>
               </a:srgbClr>
@@ -6893,7 +6780,7 @@
           <a:bodyPr wrap="square" rtlCol="0" anchor="ctr"/>
           <a:lstStyle/>
           <a:p>
-            <a:pPr indent="0" marL="0">
+            <a:pPr marL="0" indent="0">
               <a:buNone/>
             </a:pPr>
             <a:r>
@@ -6929,7 +6816,7 @@
           <a:bodyPr wrap="square" rtlCol="0" anchor="ctr"/>
           <a:lstStyle/>
           <a:p>
-            <a:pPr indent="0" marL="0">
+            <a:pPr marL="0" indent="0">
               <a:buNone/>
             </a:pPr>
             <a:r>
@@ -6965,7 +6852,7 @@
           </a:solidFill>
           <a:ln/>
           <a:effectLst>
-            <a:outerShdw sx="100000" sy="100000" kx="0" ky="0" algn="bl" rotWithShape="0" blurRad="101600" dist="38100" dir="8100000">
+            <a:outerShdw blurRad="101600" dist="38100" dir="8100000" algn="bl" rotWithShape="0">
               <a:srgbClr val="000000">
                 <a:alpha val="18000"/>
               </a:srgbClr>
@@ -7014,7 +6901,7 @@
           <a:bodyPr wrap="square" rtlCol="0" anchor="ctr"/>
           <a:lstStyle/>
           <a:p>
-            <a:pPr indent="0" marL="0">
+            <a:pPr marL="0" indent="0">
               <a:buNone/>
             </a:pPr>
             <a:r>
@@ -7050,7 +6937,7 @@
           <a:bodyPr wrap="square" rtlCol="0" anchor="ctr"/>
           <a:lstStyle/>
           <a:p>
-            <a:pPr indent="0" marL="0">
+            <a:pPr marL="0" indent="0">
               <a:buNone/>
             </a:pPr>
             <a:r>
@@ -7086,7 +6973,7 @@
           </a:solidFill>
           <a:ln/>
           <a:effectLst>
-            <a:outerShdw sx="100000" sy="100000" kx="0" ky="0" algn="bl" rotWithShape="0" blurRad="101600" dist="38100" dir="8100000">
+            <a:outerShdw blurRad="101600" dist="38100" dir="8100000" algn="bl" rotWithShape="0">
               <a:srgbClr val="000000">
                 <a:alpha val="18000"/>
               </a:srgbClr>
@@ -7135,7 +7022,7 @@
           <a:bodyPr wrap="square" rtlCol="0" anchor="ctr"/>
           <a:lstStyle/>
           <a:p>
-            <a:pPr indent="0" marL="0">
+            <a:pPr marL="0" indent="0">
               <a:buNone/>
             </a:pPr>
             <a:r>
@@ -7171,7 +7058,7 @@
           <a:bodyPr wrap="square" rtlCol="0" anchor="ctr"/>
           <a:lstStyle/>
           <a:p>
-            <a:pPr indent="0" marL="0">
+            <a:pPr marL="0" indent="0">
               <a:buNone/>
             </a:pPr>
             <a:r>
@@ -7207,7 +7094,7 @@
           <a:bodyPr wrap="square" rtlCol="0" anchor="ctr"/>
           <a:lstStyle/>
           <a:p>
-            <a:pPr algn="ctr" indent="0" marL="0">
+            <a:pPr marL="0" indent="0" algn="ctr">
               <a:buNone/>
             </a:pPr>
             <a:r>
@@ -7238,6 +7125,7 @@
         <a:solidFill>
           <a:srgbClr val="1B3A6B"/>
         </a:solidFill>
+        <a:effectLst/>
       </p:bgPr>
     </p:bg>
     <p:spTree>
@@ -7315,7 +7203,7 @@
           <a:bodyPr wrap="square" rtlCol="0" anchor="ctr"/>
           <a:lstStyle/>
           <a:p>
-            <a:pPr algn="ctr" indent="0" marL="0">
+            <a:pPr marL="0" indent="0" algn="ctr">
               <a:buNone/>
             </a:pPr>
             <a:r>
@@ -7353,7 +7241,7 @@
           <a:bodyPr wrap="square" rtlCol="0" anchor="ctr"/>
           <a:lstStyle/>
           <a:p>
-            <a:pPr algn="ctr" indent="0" marL="0">
+            <a:pPr marL="0" indent="0" algn="ctr">
               <a:buNone/>
             </a:pPr>
             <a:r>
@@ -7384,6 +7272,7 @@
         <a:solidFill>
           <a:srgbClr val="FFFFFF"/>
         </a:solidFill>
+        <a:effectLst/>
       </p:bgPr>
     </p:bg>
     <p:spTree>
@@ -7441,7 +7330,7 @@
           <a:bodyPr wrap="square" lIns="0" tIns="0" rIns="0" bIns="0" rtlCol="0" anchor="ctr"/>
           <a:lstStyle/>
           <a:p>
-            <a:pPr indent="0" marL="0">
+            <a:pPr marL="0" indent="0">
               <a:buNone/>
             </a:pPr>
             <a:r>
@@ -7497,7 +7386,7 @@
           <a:bodyPr wrap="square" lIns="0" tIns="0" rIns="0" bIns="0" rtlCol="0" anchor="ctr"/>
           <a:lstStyle/>
           <a:p>
-            <a:pPr algn="ctr" indent="0" marL="0">
+            <a:pPr marL="0" indent="0" algn="ctr">
               <a:buNone/>
             </a:pPr>
             <a:r>
@@ -7713,7 +7602,7 @@
           <a:bodyPr wrap="square" rtlCol="0" anchor="ctr"/>
           <a:lstStyle/>
           <a:p>
-            <a:pPr algn="l" indent="0" marL="0">
+            <a:pPr marL="0" indent="0" algn="l">
               <a:buNone/>
             </a:pPr>
             <a:r>
@@ -7744,6 +7633,7 @@
         <a:solidFill>
           <a:srgbClr val="1B3A6B"/>
         </a:solidFill>
+        <a:effectLst/>
       </p:bgPr>
     </p:bg>
     <p:spTree>
@@ -7821,7 +7711,7 @@
           <a:bodyPr wrap="square" rtlCol="0" anchor="ctr"/>
           <a:lstStyle/>
           <a:p>
-            <a:pPr algn="ctr" indent="0" marL="0">
+            <a:pPr marL="0" indent="0" algn="ctr">
               <a:buNone/>
             </a:pPr>
             <a:r>
@@ -7859,7 +7749,7 @@
           <a:bodyPr wrap="square" rtlCol="0" anchor="ctr"/>
           <a:lstStyle/>
           <a:p>
-            <a:pPr algn="ctr" indent="0" marL="0">
+            <a:pPr marL="0" indent="0" algn="ctr">
               <a:buNone/>
             </a:pPr>
             <a:r>
@@ -7890,6 +7780,7 @@
         <a:solidFill>
           <a:srgbClr val="FFFFFF"/>
         </a:solidFill>
+        <a:effectLst/>
       </p:bgPr>
     </p:bg>
     <p:spTree>
@@ -7947,7 +7838,7 @@
           <a:bodyPr wrap="square" lIns="0" tIns="0" rIns="0" bIns="0" rtlCol="0" anchor="ctr"/>
           <a:lstStyle/>
           <a:p>
-            <a:pPr indent="0" marL="0">
+            <a:pPr marL="0" indent="0">
               <a:buNone/>
             </a:pPr>
             <a:r>
@@ -8003,7 +7894,7 @@
           <a:bodyPr wrap="square" lIns="0" tIns="0" rIns="0" bIns="0" rtlCol="0" anchor="ctr"/>
           <a:lstStyle/>
           <a:p>
-            <a:pPr algn="ctr" indent="0" marL="0">
+            <a:pPr marL="0" indent="0" algn="ctr">
               <a:buNone/>
             </a:pPr>
             <a:r>
@@ -8159,7 +8050,7 @@
           <a:bodyPr wrap="square" rtlCol="0" anchor="ctr"/>
           <a:lstStyle/>
           <a:p>
-            <a:pPr algn="l" indent="0" marL="0">
+            <a:pPr marL="0" indent="0" algn="l">
               <a:buNone/>
             </a:pPr>
             <a:r>
@@ -8190,6 +8081,7 @@
         <a:solidFill>
           <a:srgbClr val="1B3A6B"/>
         </a:solidFill>
+        <a:effectLst/>
       </p:bgPr>
     </p:bg>
     <p:spTree>
@@ -8267,7 +8159,7 @@
           <a:bodyPr wrap="square" rtlCol="0" anchor="ctr"/>
           <a:lstStyle/>
           <a:p>
-            <a:pPr algn="ctr" indent="0" marL="0">
+            <a:pPr marL="0" indent="0" algn="ctr">
               <a:buNone/>
             </a:pPr>
             <a:r>
@@ -8305,7 +8197,7 @@
           <a:bodyPr wrap="square" rtlCol="0" anchor="ctr"/>
           <a:lstStyle/>
           <a:p>
-            <a:pPr algn="ctr" indent="0" marL="0">
+            <a:pPr marL="0" indent="0" algn="ctr">
               <a:buNone/>
             </a:pPr>
             <a:r>
@@ -8336,6 +8228,7 @@
         <a:solidFill>
           <a:srgbClr val="FFFFFF"/>
         </a:solidFill>
+        <a:effectLst/>
       </p:bgPr>
     </p:bg>
     <p:spTree>
@@ -8393,7 +8286,7 @@
           <a:bodyPr wrap="square" lIns="0" tIns="0" rIns="0" bIns="0" rtlCol="0" anchor="ctr"/>
           <a:lstStyle/>
           <a:p>
-            <a:pPr indent="0" marL="0">
+            <a:pPr marL="0" indent="0">
               <a:buNone/>
             </a:pPr>
             <a:r>
@@ -8449,7 +8342,7 @@
           <a:bodyPr wrap="square" lIns="0" tIns="0" rIns="0" bIns="0" rtlCol="0" anchor="ctr"/>
           <a:lstStyle/>
           <a:p>
-            <a:pPr algn="ctr" indent="0" marL="0">
+            <a:pPr marL="0" indent="0" algn="ctr">
               <a:buNone/>
             </a:pPr>
             <a:r>
@@ -8487,11 +8380,41 @@
             <a:tbl>
               <a:tblPr/>
               <a:tblGrid>
-                <a:gridCol w="1463040"/>
-                <a:gridCol w="1645920"/>
-                <a:gridCol w="1828800"/>
-                <a:gridCol w="1828800"/>
-                <a:gridCol w="1828800"/>
+                <a:gridCol w="1463040">
+                  <a:extLst>
+                    <a:ext uri="{9D8B030D-6E8A-4147-A177-3AD203B41FA5}">
+                      <a16:colId xmlns:a16="http://schemas.microsoft.com/office/drawing/2014/main" val="20000"/>
+                    </a:ext>
+                  </a:extLst>
+                </a:gridCol>
+                <a:gridCol w="1645920">
+                  <a:extLst>
+                    <a:ext uri="{9D8B030D-6E8A-4147-A177-3AD203B41FA5}">
+                      <a16:colId xmlns:a16="http://schemas.microsoft.com/office/drawing/2014/main" val="20001"/>
+                    </a:ext>
+                  </a:extLst>
+                </a:gridCol>
+                <a:gridCol w="1828800">
+                  <a:extLst>
+                    <a:ext uri="{9D8B030D-6E8A-4147-A177-3AD203B41FA5}">
+                      <a16:colId xmlns:a16="http://schemas.microsoft.com/office/drawing/2014/main" val="20002"/>
+                    </a:ext>
+                  </a:extLst>
+                </a:gridCol>
+                <a:gridCol w="1828800">
+                  <a:extLst>
+                    <a:ext uri="{9D8B030D-6E8A-4147-A177-3AD203B41FA5}">
+                      <a16:colId xmlns:a16="http://schemas.microsoft.com/office/drawing/2014/main" val="20003"/>
+                    </a:ext>
+                  </a:extLst>
+                </a:gridCol>
+                <a:gridCol w="1828800">
+                  <a:extLst>
+                    <a:ext uri="{9D8B030D-6E8A-4147-A177-3AD203B41FA5}">
+                      <a16:colId xmlns:a16="http://schemas.microsoft.com/office/drawing/2014/main" val="20004"/>
+                    </a:ext>
+                  </a:extLst>
+                </a:gridCol>
               </a:tblGrid>
               <a:tr h="0">
                 <a:tc>
@@ -8499,7 +8422,7 @@
                     <a:bodyPr/>
                     <a:lstStyle/>
                     <a:p>
-                      <a:pPr algn="ctr" indent="0" marL="0">
+                      <a:pPr marL="0" indent="0" algn="ctr">
                         <a:buNone/>
                       </a:pPr>
                       <a:r>
@@ -8513,7 +8436,7 @@
                       <a:endParaRPr lang="en-US" sz="1200" dirty="0"/>
                     </a:p>
                   </a:txBody>
-                  <a:tcPr marL="91440" marR="91440" marT="45720" marB="45720">
+                  <a:tcPr>
                     <a:lnL w="6350" cap="flat" cmpd="sng" algn="ctr">
                       <a:solidFill>
                         <a:srgbClr val="CCCCCC"/>
@@ -8560,7 +8483,7 @@
                     <a:bodyPr/>
                     <a:lstStyle/>
                     <a:p>
-                      <a:pPr algn="ctr" indent="0" marL="0">
+                      <a:pPr marL="0" indent="0" algn="ctr">
                         <a:buNone/>
                       </a:pPr>
                       <a:r>
@@ -8574,7 +8497,7 @@
                       <a:endParaRPr lang="en-US" sz="1200" dirty="0"/>
                     </a:p>
                   </a:txBody>
-                  <a:tcPr marL="91440" marR="91440" marT="45720" marB="45720">
+                  <a:tcPr>
                     <a:lnL w="6350" cap="flat" cmpd="sng" algn="ctr">
                       <a:solidFill>
                         <a:srgbClr val="CCCCCC"/>
@@ -8621,7 +8544,7 @@
                     <a:bodyPr/>
                     <a:lstStyle/>
                     <a:p>
-                      <a:pPr algn="ctr" indent="0" marL="0">
+                      <a:pPr marL="0" indent="0" algn="ctr">
                         <a:buNone/>
                       </a:pPr>
                       <a:r>
@@ -8635,7 +8558,7 @@
                       <a:endParaRPr lang="en-US" sz="1200" dirty="0"/>
                     </a:p>
                   </a:txBody>
-                  <a:tcPr marL="91440" marR="91440" marT="45720" marB="45720">
+                  <a:tcPr>
                     <a:lnL w="6350" cap="flat" cmpd="sng" algn="ctr">
                       <a:solidFill>
                         <a:srgbClr val="CCCCCC"/>
@@ -8682,7 +8605,7 @@
                     <a:bodyPr/>
                     <a:lstStyle/>
                     <a:p>
-                      <a:pPr algn="ctr" indent="0" marL="0">
+                      <a:pPr marL="0" indent="0" algn="ctr">
                         <a:buNone/>
                       </a:pPr>
                       <a:r>
@@ -8696,7 +8619,7 @@
                       <a:endParaRPr lang="en-US" sz="1200" dirty="0"/>
                     </a:p>
                   </a:txBody>
-                  <a:tcPr marL="91440" marR="91440" marT="45720" marB="45720">
+                  <a:tcPr>
                     <a:lnL w="6350" cap="flat" cmpd="sng" algn="ctr">
                       <a:solidFill>
                         <a:srgbClr val="CCCCCC"/>
@@ -8743,7 +8666,7 @@
                     <a:bodyPr/>
                     <a:lstStyle/>
                     <a:p>
-                      <a:pPr algn="ctr" indent="0" marL="0">
+                      <a:pPr marL="0" indent="0" algn="ctr">
                         <a:buNone/>
                       </a:pPr>
                       <a:r>
@@ -8757,7 +8680,7 @@
                       <a:endParaRPr lang="en-US" sz="1200" dirty="0"/>
                     </a:p>
                   </a:txBody>
-                  <a:tcPr marL="91440" marR="91440" marT="45720" marB="45720">
+                  <a:tcPr>
                     <a:lnL w="6350" cap="flat" cmpd="sng" algn="ctr">
                       <a:solidFill>
                         <a:srgbClr val="CCCCCC"/>
@@ -8799,6 +8722,11 @@
                     </a:solidFill>
                   </a:tcPr>
                 </a:tc>
+                <a:extLst>
+                  <a:ext uri="{0D108BD9-81ED-4DB2-BD59-A6C34878D82A}">
+                    <a16:rowId xmlns:a16="http://schemas.microsoft.com/office/drawing/2014/main" val="10000"/>
+                  </a:ext>
+                </a:extLst>
               </a:tr>
               <a:tr h="0">
                 <a:tc>
@@ -8806,7 +8734,7 @@
                     <a:bodyPr/>
                     <a:lstStyle/>
                     <a:p>
-                      <a:pPr algn="ctr" indent="0" marL="0">
+                      <a:pPr marL="0" indent="0" algn="ctr">
                         <a:buNone/>
                       </a:pPr>
                       <a:r>
@@ -8820,7 +8748,7 @@
                       <a:endParaRPr lang="en-US" sz="1100" dirty="0"/>
                     </a:p>
                   </a:txBody>
-                  <a:tcPr marL="91440" marR="91440" marT="45720" marB="45720">
+                  <a:tcPr>
                     <a:lnL w="6350" cap="flat" cmpd="sng" algn="ctr">
                       <a:solidFill>
                         <a:srgbClr val="CCCCCC"/>
@@ -8864,7 +8792,7 @@
                     <a:bodyPr/>
                     <a:lstStyle/>
                     <a:p>
-                      <a:pPr algn="ctr" indent="0" marL="0">
+                      <a:pPr marL="0" indent="0" algn="ctr">
                         <a:buNone/>
                       </a:pPr>
                       <a:r>
@@ -8878,7 +8806,7 @@
                       <a:endParaRPr lang="en-US" sz="1100" dirty="0"/>
                     </a:p>
                   </a:txBody>
-                  <a:tcPr marL="91440" marR="91440" marT="45720" marB="45720">
+                  <a:tcPr>
                     <a:lnL w="6350" cap="flat" cmpd="sng" algn="ctr">
                       <a:solidFill>
                         <a:srgbClr val="CCCCCC"/>
@@ -8922,7 +8850,7 @@
                     <a:bodyPr/>
                     <a:lstStyle/>
                     <a:p>
-                      <a:pPr algn="ctr" indent="0" marL="0">
+                      <a:pPr marL="0" indent="0" algn="ctr">
                         <a:buNone/>
                       </a:pPr>
                       <a:r>
@@ -8936,7 +8864,7 @@
                       <a:endParaRPr lang="en-US" sz="1100" dirty="0"/>
                     </a:p>
                   </a:txBody>
-                  <a:tcPr marL="91440" marR="91440" marT="45720" marB="45720">
+                  <a:tcPr>
                     <a:lnL w="6350" cap="flat" cmpd="sng" algn="ctr">
                       <a:solidFill>
                         <a:srgbClr val="CCCCCC"/>
@@ -8980,7 +8908,7 @@
                     <a:bodyPr/>
                     <a:lstStyle/>
                     <a:p>
-                      <a:pPr algn="ctr" indent="0" marL="0">
+                      <a:pPr marL="0" indent="0" algn="ctr">
                         <a:buNone/>
                       </a:pPr>
                       <a:r>
@@ -8994,7 +8922,7 @@
                       <a:endParaRPr lang="en-US" sz="1100" dirty="0"/>
                     </a:p>
                   </a:txBody>
-                  <a:tcPr marL="91440" marR="91440" marT="45720" marB="45720">
+                  <a:tcPr>
                     <a:lnL w="6350" cap="flat" cmpd="sng" algn="ctr">
                       <a:solidFill>
                         <a:srgbClr val="CCCCCC"/>
@@ -9038,7 +8966,7 @@
                     <a:bodyPr/>
                     <a:lstStyle/>
                     <a:p>
-                      <a:pPr algn="ctr" indent="0" marL="0">
+                      <a:pPr marL="0" indent="0" algn="ctr">
                         <a:buNone/>
                       </a:pPr>
                       <a:r>
@@ -9052,7 +8980,7 @@
                       <a:endParaRPr lang="en-US" sz="1100" dirty="0"/>
                     </a:p>
                   </a:txBody>
-                  <a:tcPr marL="91440" marR="91440" marT="45720" marB="45720">
+                  <a:tcPr>
                     <a:lnL w="6350" cap="flat" cmpd="sng" algn="ctr">
                       <a:solidFill>
                         <a:srgbClr val="CCCCCC"/>
@@ -9091,6 +9019,11 @@
                     </a:lnB>
                   </a:tcPr>
                 </a:tc>
+                <a:extLst>
+                  <a:ext uri="{0D108BD9-81ED-4DB2-BD59-A6C34878D82A}">
+                    <a16:rowId xmlns:a16="http://schemas.microsoft.com/office/drawing/2014/main" val="10001"/>
+                  </a:ext>
+                </a:extLst>
               </a:tr>
               <a:tr h="0">
                 <a:tc>
@@ -9098,7 +9031,7 @@
                     <a:bodyPr/>
                     <a:lstStyle/>
                     <a:p>
-                      <a:pPr algn="ctr" indent="0" marL="0">
+                      <a:pPr marL="0" indent="0" algn="ctr">
                         <a:buNone/>
                       </a:pPr>
                       <a:r>
@@ -9112,7 +9045,7 @@
                       <a:endParaRPr lang="en-US" sz="1100" dirty="0"/>
                     </a:p>
                   </a:txBody>
-                  <a:tcPr marL="91440" marR="91440" marT="45720" marB="45720">
+                  <a:tcPr>
                     <a:lnL w="6350" cap="flat" cmpd="sng" algn="ctr">
                       <a:solidFill>
                         <a:srgbClr val="CCCCCC"/>
@@ -9156,7 +9089,7 @@
                     <a:bodyPr/>
                     <a:lstStyle/>
                     <a:p>
-                      <a:pPr algn="ctr" indent="0" marL="0">
+                      <a:pPr marL="0" indent="0" algn="ctr">
                         <a:buNone/>
                       </a:pPr>
                       <a:r>
@@ -9170,7 +9103,7 @@
                       <a:endParaRPr lang="en-US" sz="1100" dirty="0"/>
                     </a:p>
                   </a:txBody>
-                  <a:tcPr marL="91440" marR="91440" marT="45720" marB="45720">
+                  <a:tcPr>
                     <a:lnL w="6350" cap="flat" cmpd="sng" algn="ctr">
                       <a:solidFill>
                         <a:srgbClr val="CCCCCC"/>
@@ -9214,7 +9147,7 @@
                     <a:bodyPr/>
                     <a:lstStyle/>
                     <a:p>
-                      <a:pPr algn="ctr" indent="0" marL="0">
+                      <a:pPr marL="0" indent="0" algn="ctr">
                         <a:buNone/>
                       </a:pPr>
                       <a:r>
@@ -9228,7 +9161,7 @@
                       <a:endParaRPr lang="en-US" sz="1100" dirty="0"/>
                     </a:p>
                   </a:txBody>
-                  <a:tcPr marL="91440" marR="91440" marT="45720" marB="45720">
+                  <a:tcPr>
                     <a:lnL w="6350" cap="flat" cmpd="sng" algn="ctr">
                       <a:solidFill>
                         <a:srgbClr val="CCCCCC"/>
@@ -9272,7 +9205,7 @@
                     <a:bodyPr/>
                     <a:lstStyle/>
                     <a:p>
-                      <a:pPr algn="ctr" indent="0" marL="0">
+                      <a:pPr marL="0" indent="0" algn="ctr">
                         <a:buNone/>
                       </a:pPr>
                       <a:r>
@@ -9286,7 +9219,7 @@
                       <a:endParaRPr lang="en-US" sz="1100" dirty="0"/>
                     </a:p>
                   </a:txBody>
-                  <a:tcPr marL="91440" marR="91440" marT="45720" marB="45720">
+                  <a:tcPr>
                     <a:lnL w="6350" cap="flat" cmpd="sng" algn="ctr">
                       <a:solidFill>
                         <a:srgbClr val="CCCCCC"/>
@@ -9330,7 +9263,7 @@
                     <a:bodyPr/>
                     <a:lstStyle/>
                     <a:p>
-                      <a:pPr algn="ctr" indent="0" marL="0">
+                      <a:pPr marL="0" indent="0" algn="ctr">
                         <a:buNone/>
                       </a:pPr>
                       <a:r>
@@ -9344,7 +9277,7 @@
                       <a:endParaRPr lang="en-US" sz="1100" dirty="0"/>
                     </a:p>
                   </a:txBody>
-                  <a:tcPr marL="91440" marR="91440" marT="45720" marB="45720">
+                  <a:tcPr>
                     <a:lnL w="6350" cap="flat" cmpd="sng" algn="ctr">
                       <a:solidFill>
                         <a:srgbClr val="CCCCCC"/>
@@ -9383,6 +9316,11 @@
                     </a:lnB>
                   </a:tcPr>
                 </a:tc>
+                <a:extLst>
+                  <a:ext uri="{0D108BD9-81ED-4DB2-BD59-A6C34878D82A}">
+                    <a16:rowId xmlns:a16="http://schemas.microsoft.com/office/drawing/2014/main" val="10002"/>
+                  </a:ext>
+                </a:extLst>
               </a:tr>
               <a:tr h="0">
                 <a:tc>
@@ -9390,7 +9328,7 @@
                     <a:bodyPr/>
                     <a:lstStyle/>
                     <a:p>
-                      <a:pPr algn="ctr" indent="0" marL="0">
+                      <a:pPr marL="0" indent="0" algn="ctr">
                         <a:buNone/>
                       </a:pPr>
                       <a:r>
@@ -9404,7 +9342,7 @@
                       <a:endParaRPr lang="en-US" sz="1100" dirty="0"/>
                     </a:p>
                   </a:txBody>
-                  <a:tcPr marL="91440" marR="91440" marT="45720" marB="45720">
+                  <a:tcPr>
                     <a:lnL w="6350" cap="flat" cmpd="sng" algn="ctr">
                       <a:solidFill>
                         <a:srgbClr val="CCCCCC"/>
@@ -9448,7 +9386,7 @@
                     <a:bodyPr/>
                     <a:lstStyle/>
                     <a:p>
-                      <a:pPr algn="ctr" indent="0" marL="0">
+                      <a:pPr marL="0" indent="0" algn="ctr">
                         <a:buNone/>
                       </a:pPr>
                       <a:r>
@@ -9462,7 +9400,7 @@
                       <a:endParaRPr lang="en-US" sz="1100" dirty="0"/>
                     </a:p>
                   </a:txBody>
-                  <a:tcPr marL="91440" marR="91440" marT="45720" marB="45720">
+                  <a:tcPr>
                     <a:lnL w="6350" cap="flat" cmpd="sng" algn="ctr">
                       <a:solidFill>
                         <a:srgbClr val="CCCCCC"/>
@@ -9506,7 +9444,7 @@
                     <a:bodyPr/>
                     <a:lstStyle/>
                     <a:p>
-                      <a:pPr algn="ctr" indent="0" marL="0">
+                      <a:pPr marL="0" indent="0" algn="ctr">
                         <a:buNone/>
                       </a:pPr>
                       <a:r>
@@ -9520,7 +9458,7 @@
                       <a:endParaRPr lang="en-US" sz="1100" dirty="0"/>
                     </a:p>
                   </a:txBody>
-                  <a:tcPr marL="91440" marR="91440" marT="45720" marB="45720">
+                  <a:tcPr>
                     <a:lnL w="6350" cap="flat" cmpd="sng" algn="ctr">
                       <a:solidFill>
                         <a:srgbClr val="CCCCCC"/>
@@ -9564,7 +9502,7 @@
                     <a:bodyPr/>
                     <a:lstStyle/>
                     <a:p>
-                      <a:pPr algn="ctr" indent="0" marL="0">
+                      <a:pPr marL="0" indent="0" algn="ctr">
                         <a:buNone/>
                       </a:pPr>
                       <a:r>
@@ -9578,7 +9516,7 @@
                       <a:endParaRPr lang="en-US" sz="1100" dirty="0"/>
                     </a:p>
                   </a:txBody>
-                  <a:tcPr marL="91440" marR="91440" marT="45720" marB="45720">
+                  <a:tcPr>
                     <a:lnL w="6350" cap="flat" cmpd="sng" algn="ctr">
                       <a:solidFill>
                         <a:srgbClr val="CCCCCC"/>
@@ -9622,7 +9560,7 @@
                     <a:bodyPr/>
                     <a:lstStyle/>
                     <a:p>
-                      <a:pPr algn="ctr" indent="0" marL="0">
+                      <a:pPr marL="0" indent="0" algn="ctr">
                         <a:buNone/>
                       </a:pPr>
                       <a:r>
@@ -9636,7 +9574,7 @@
                       <a:endParaRPr lang="en-US" sz="1100" dirty="0"/>
                     </a:p>
                   </a:txBody>
-                  <a:tcPr marL="91440" marR="91440" marT="45720" marB="45720">
+                  <a:tcPr>
                     <a:lnL w="6350" cap="flat" cmpd="sng" algn="ctr">
                       <a:solidFill>
                         <a:srgbClr val="CCCCCC"/>
@@ -9675,6 +9613,11 @@
                     </a:lnB>
                   </a:tcPr>
                 </a:tc>
+                <a:extLst>
+                  <a:ext uri="{0D108BD9-81ED-4DB2-BD59-A6C34878D82A}">
+                    <a16:rowId xmlns:a16="http://schemas.microsoft.com/office/drawing/2014/main" val="10003"/>
+                  </a:ext>
+                </a:extLst>
               </a:tr>
               <a:tr h="0">
                 <a:tc>
@@ -9682,7 +9625,7 @@
                     <a:bodyPr/>
                     <a:lstStyle/>
                     <a:p>
-                      <a:pPr algn="ctr" indent="0" marL="0">
+                      <a:pPr marL="0" indent="0" algn="ctr">
                         <a:buNone/>
                       </a:pPr>
                       <a:r>
@@ -9696,7 +9639,7 @@
                       <a:endParaRPr lang="en-US" sz="1100" dirty="0"/>
                     </a:p>
                   </a:txBody>
-                  <a:tcPr marL="91440" marR="91440" marT="45720" marB="45720">
+                  <a:tcPr>
                     <a:lnL w="6350" cap="flat" cmpd="sng" algn="ctr">
                       <a:solidFill>
                         <a:srgbClr val="CCCCCC"/>
@@ -9740,7 +9683,7 @@
                     <a:bodyPr/>
                     <a:lstStyle/>
                     <a:p>
-                      <a:pPr algn="ctr" indent="0" marL="0">
+                      <a:pPr marL="0" indent="0" algn="ctr">
                         <a:buNone/>
                       </a:pPr>
                       <a:r>
@@ -9754,7 +9697,7 @@
                       <a:endParaRPr lang="en-US" sz="1100" dirty="0"/>
                     </a:p>
                   </a:txBody>
-                  <a:tcPr marL="91440" marR="91440" marT="45720" marB="45720">
+                  <a:tcPr>
                     <a:lnL w="6350" cap="flat" cmpd="sng" algn="ctr">
                       <a:solidFill>
                         <a:srgbClr val="CCCCCC"/>
@@ -9798,7 +9741,7 @@
                     <a:bodyPr/>
                     <a:lstStyle/>
                     <a:p>
-                      <a:pPr algn="ctr" indent="0" marL="0">
+                      <a:pPr marL="0" indent="0" algn="ctr">
                         <a:buNone/>
                       </a:pPr>
                       <a:r>
@@ -9812,7 +9755,7 @@
                       <a:endParaRPr lang="en-US" sz="1100" dirty="0"/>
                     </a:p>
                   </a:txBody>
-                  <a:tcPr marL="91440" marR="91440" marT="45720" marB="45720">
+                  <a:tcPr>
                     <a:lnL w="6350" cap="flat" cmpd="sng" algn="ctr">
                       <a:solidFill>
                         <a:srgbClr val="CCCCCC"/>
@@ -9856,7 +9799,7 @@
                     <a:bodyPr/>
                     <a:lstStyle/>
                     <a:p>
-                      <a:pPr algn="ctr" indent="0" marL="0">
+                      <a:pPr marL="0" indent="0" algn="ctr">
                         <a:buNone/>
                       </a:pPr>
                       <a:r>
@@ -9870,7 +9813,7 @@
                       <a:endParaRPr lang="en-US" sz="1100" dirty="0"/>
                     </a:p>
                   </a:txBody>
-                  <a:tcPr marL="91440" marR="91440" marT="45720" marB="45720">
+                  <a:tcPr>
                     <a:lnL w="6350" cap="flat" cmpd="sng" algn="ctr">
                       <a:solidFill>
                         <a:srgbClr val="CCCCCC"/>
@@ -9914,7 +9857,7 @@
                     <a:bodyPr/>
                     <a:lstStyle/>
                     <a:p>
-                      <a:pPr algn="ctr" indent="0" marL="0">
+                      <a:pPr marL="0" indent="0" algn="ctr">
                         <a:buNone/>
                       </a:pPr>
                       <a:r>
@@ -9928,7 +9871,7 @@
                       <a:endParaRPr lang="en-US" sz="1100" dirty="0"/>
                     </a:p>
                   </a:txBody>
-                  <a:tcPr marL="91440" marR="91440" marT="45720" marB="45720">
+                  <a:tcPr>
                     <a:lnL w="6350" cap="flat" cmpd="sng" algn="ctr">
                       <a:solidFill>
                         <a:srgbClr val="CCCCCC"/>
@@ -9967,6 +9910,11 @@
                     </a:lnB>
                   </a:tcPr>
                 </a:tc>
+                <a:extLst>
+                  <a:ext uri="{0D108BD9-81ED-4DB2-BD59-A6C34878D82A}">
+                    <a16:rowId xmlns:a16="http://schemas.microsoft.com/office/drawing/2014/main" val="10004"/>
+                  </a:ext>
+                </a:extLst>
               </a:tr>
               <a:tr h="0">
                 <a:tc>
@@ -9974,7 +9922,7 @@
                     <a:bodyPr/>
                     <a:lstStyle/>
                     <a:p>
-                      <a:pPr algn="ctr" indent="0" marL="0">
+                      <a:pPr marL="0" indent="0" algn="ctr">
                         <a:buNone/>
                       </a:pPr>
                       <a:r>
@@ -9988,7 +9936,7 @@
                       <a:endParaRPr lang="en-US" sz="1100" dirty="0"/>
                     </a:p>
                   </a:txBody>
-                  <a:tcPr marL="91440" marR="91440" marT="45720" marB="45720">
+                  <a:tcPr>
                     <a:lnL w="6350" cap="flat" cmpd="sng" algn="ctr">
                       <a:solidFill>
                         <a:srgbClr val="CCCCCC"/>
@@ -10032,7 +9980,7 @@
                     <a:bodyPr/>
                     <a:lstStyle/>
                     <a:p>
-                      <a:pPr algn="ctr" indent="0" marL="0">
+                      <a:pPr marL="0" indent="0" algn="ctr">
                         <a:buNone/>
                       </a:pPr>
                       <a:r>
@@ -10046,7 +9994,7 @@
                       <a:endParaRPr lang="en-US" sz="1100" dirty="0"/>
                     </a:p>
                   </a:txBody>
-                  <a:tcPr marL="91440" marR="91440" marT="45720" marB="45720">
+                  <a:tcPr>
                     <a:lnL w="6350" cap="flat" cmpd="sng" algn="ctr">
                       <a:solidFill>
                         <a:srgbClr val="CCCCCC"/>
@@ -10090,7 +10038,7 @@
                     <a:bodyPr/>
                     <a:lstStyle/>
                     <a:p>
-                      <a:pPr algn="ctr" indent="0" marL="0">
+                      <a:pPr marL="0" indent="0" algn="ctr">
                         <a:buNone/>
                       </a:pPr>
                       <a:r>
@@ -10104,7 +10052,7 @@
                       <a:endParaRPr lang="en-US" sz="1100" dirty="0"/>
                     </a:p>
                   </a:txBody>
-                  <a:tcPr marL="91440" marR="91440" marT="45720" marB="45720">
+                  <a:tcPr>
                     <a:lnL w="6350" cap="flat" cmpd="sng" algn="ctr">
                       <a:solidFill>
                         <a:srgbClr val="CCCCCC"/>
@@ -10148,7 +10096,7 @@
                     <a:bodyPr/>
                     <a:lstStyle/>
                     <a:p>
-                      <a:pPr algn="ctr" indent="0" marL="0">
+                      <a:pPr marL="0" indent="0" algn="ctr">
                         <a:buNone/>
                       </a:pPr>
                       <a:r>
@@ -10162,7 +10110,7 @@
                       <a:endParaRPr lang="en-US" sz="1100" dirty="0"/>
                     </a:p>
                   </a:txBody>
-                  <a:tcPr marL="91440" marR="91440" marT="45720" marB="45720">
+                  <a:tcPr>
                     <a:lnL w="6350" cap="flat" cmpd="sng" algn="ctr">
                       <a:solidFill>
                         <a:srgbClr val="CCCCCC"/>
@@ -10206,7 +10154,7 @@
                     <a:bodyPr/>
                     <a:lstStyle/>
                     <a:p>
-                      <a:pPr algn="ctr" indent="0" marL="0">
+                      <a:pPr marL="0" indent="0" algn="ctr">
                         <a:buNone/>
                       </a:pPr>
                       <a:r>
@@ -10220,7 +10168,7 @@
                       <a:endParaRPr lang="en-US" sz="1100" dirty="0"/>
                     </a:p>
                   </a:txBody>
-                  <a:tcPr marL="91440" marR="91440" marT="45720" marB="45720">
+                  <a:tcPr>
                     <a:lnL w="6350" cap="flat" cmpd="sng" algn="ctr">
                       <a:solidFill>
                         <a:srgbClr val="CCCCCC"/>
@@ -10259,6 +10207,11 @@
                     </a:lnB>
                   </a:tcPr>
                 </a:tc>
+                <a:extLst>
+                  <a:ext uri="{0D108BD9-81ED-4DB2-BD59-A6C34878D82A}">
+                    <a16:rowId xmlns:a16="http://schemas.microsoft.com/office/drawing/2014/main" val="10005"/>
+                  </a:ext>
+                </a:extLst>
               </a:tr>
             </a:tbl>
           </a:graphicData>
@@ -10289,7 +10242,7 @@
       </p:sp>
       <p:sp>
         <p:nvSpPr>
-          <p:cNvPr id="8" name="Text 5"/>
+          <p:cNvPr id="6" name="Text 5"/>
           <p:cNvSpPr/>
           <p:nvPr/>
         </p:nvSpPr>
@@ -10308,7 +10261,7 @@
           <a:bodyPr wrap="square" rtlCol="0" anchor="ctr"/>
           <a:lstStyle/>
           <a:p>
-            <a:pPr algn="l" indent="0" marL="0">
+            <a:pPr marL="0" indent="0" algn="l">
               <a:buNone/>
             </a:pPr>
             <a:r>
@@ -10339,6 +10292,7 @@
         <a:solidFill>
           <a:srgbClr val="FFFFFF"/>
         </a:solidFill>
+        <a:effectLst/>
       </p:bgPr>
     </p:bg>
     <p:spTree>
@@ -10396,7 +10350,7 @@
           <a:bodyPr wrap="square" lIns="0" tIns="0" rIns="0" bIns="0" rtlCol="0" anchor="ctr"/>
           <a:lstStyle/>
           <a:p>
-            <a:pPr indent="0" marL="0">
+            <a:pPr marL="0" indent="0">
               <a:buNone/>
             </a:pPr>
             <a:r>
@@ -10452,7 +10406,7 @@
           <a:bodyPr wrap="square" lIns="0" tIns="0" rIns="0" bIns="0" rtlCol="0" anchor="ctr"/>
           <a:lstStyle/>
           <a:p>
-            <a:pPr algn="ctr" indent="0" marL="0">
+            <a:pPr marL="0" indent="0" algn="ctr">
               <a:buNone/>
             </a:pPr>
             <a:r>
@@ -10486,7 +10440,7 @@
           </a:solidFill>
           <a:ln/>
           <a:effectLst>
-            <a:outerShdw sx="100000" sy="100000" kx="0" ky="0" algn="bl" rotWithShape="0" blurRad="101600" dist="38100" dir="8100000">
+            <a:outerShdw blurRad="101600" dist="38100" dir="8100000" algn="bl" rotWithShape="0">
               <a:srgbClr val="000000">
                 <a:alpha val="18000"/>
               </a:srgbClr>
@@ -10640,7 +10594,7 @@
           </a:solidFill>
           <a:ln/>
           <a:effectLst>
-            <a:outerShdw sx="100000" sy="100000" kx="0" ky="0" algn="bl" rotWithShape="0" blurRad="101600" dist="38100" dir="8100000">
+            <a:outerShdw blurRad="101600" dist="38100" dir="8100000" algn="bl" rotWithShape="0">
               <a:srgbClr val="000000">
                 <a:alpha val="18000"/>
               </a:srgbClr>
@@ -10669,7 +10623,7 @@
           <a:bodyPr wrap="square" lIns="0" tIns="0" rIns="0" bIns="0" rtlCol="0" anchor="ctr"/>
           <a:lstStyle/>
           <a:p>
-            <a:pPr algn="ctr" indent="0" marL="0">
+            <a:pPr marL="0" indent="0" algn="ctr">
               <a:buNone/>
             </a:pPr>
             <a:r>
@@ -10705,7 +10659,7 @@
           <a:bodyPr wrap="square" lIns="0" tIns="0" rIns="0" bIns="0" rtlCol="0" anchor="ctr"/>
           <a:lstStyle/>
           <a:p>
-            <a:pPr algn="ctr" indent="0" marL="0">
+            <a:pPr marL="0" indent="0" algn="ctr">
               <a:buNone/>
             </a:pPr>
             <a:r>
@@ -10739,7 +10693,7 @@
           </a:solidFill>
           <a:ln/>
           <a:effectLst>
-            <a:outerShdw sx="100000" sy="100000" kx="0" ky="0" algn="bl" rotWithShape="0" blurRad="101600" dist="38100" dir="8100000">
+            <a:outerShdw blurRad="101600" dist="38100" dir="8100000" algn="bl" rotWithShape="0">
               <a:srgbClr val="000000">
                 <a:alpha val="18000"/>
               </a:srgbClr>
@@ -10768,7 +10722,7 @@
           <a:bodyPr wrap="square" lIns="0" tIns="0" rIns="0" bIns="0" rtlCol="0" anchor="ctr"/>
           <a:lstStyle/>
           <a:p>
-            <a:pPr algn="ctr" indent="0" marL="0">
+            <a:pPr marL="0" indent="0" algn="ctr">
               <a:buNone/>
             </a:pPr>
             <a:r>
@@ -10804,7 +10758,7 @@
           <a:bodyPr wrap="square" lIns="0" tIns="0" rIns="0" bIns="0" rtlCol="0" anchor="ctr"/>
           <a:lstStyle/>
           <a:p>
-            <a:pPr algn="ctr" indent="0" marL="0">
+            <a:pPr marL="0" indent="0" algn="ctr">
               <a:buNone/>
             </a:pPr>
             <a:r>
@@ -10838,7 +10792,7 @@
           </a:solidFill>
           <a:ln/>
           <a:effectLst>
-            <a:outerShdw sx="100000" sy="100000" kx="0" ky="0" algn="bl" rotWithShape="0" blurRad="101600" dist="38100" dir="8100000">
+            <a:outerShdw blurRad="101600" dist="38100" dir="8100000" algn="bl" rotWithShape="0">
               <a:srgbClr val="000000">
                 <a:alpha val="18000"/>
               </a:srgbClr>
@@ -10867,7 +10821,7 @@
           <a:bodyPr wrap="square" lIns="0" tIns="0" rIns="0" bIns="0" rtlCol="0" anchor="ctr"/>
           <a:lstStyle/>
           <a:p>
-            <a:pPr algn="ctr" indent="0" marL="0">
+            <a:pPr marL="0" indent="0" algn="ctr">
               <a:buNone/>
             </a:pPr>
             <a:r>
@@ -10903,7 +10857,7 @@
           <a:bodyPr wrap="square" lIns="0" tIns="0" rIns="0" bIns="0" rtlCol="0" anchor="ctr"/>
           <a:lstStyle/>
           <a:p>
-            <a:pPr algn="ctr" indent="0" marL="0">
+            <a:pPr marL="0" indent="0" algn="ctr">
               <a:buNone/>
             </a:pPr>
             <a:r>
@@ -10962,7 +10916,7 @@
           <a:bodyPr wrap="square" rtlCol="0" anchor="ctr"/>
           <a:lstStyle/>
           <a:p>
-            <a:pPr indent="0" marL="0">
+            <a:pPr marL="0" indent="0">
               <a:buNone/>
             </a:pPr>
             <a:r>
@@ -10993,6 +10947,7 @@
         <a:solidFill>
           <a:srgbClr val="FFFFFF"/>
         </a:solidFill>
+        <a:effectLst/>
       </p:bgPr>
     </p:bg>
     <p:spTree>
@@ -11050,7 +11005,7 @@
           <a:bodyPr wrap="square" lIns="0" tIns="0" rIns="0" bIns="0" rtlCol="0" anchor="ctr"/>
           <a:lstStyle/>
           <a:p>
-            <a:pPr indent="0" marL="0">
+            <a:pPr marL="0" indent="0">
               <a:buNone/>
             </a:pPr>
             <a:r>
@@ -11106,7 +11061,7 @@
           <a:bodyPr wrap="square" lIns="0" tIns="0" rIns="0" bIns="0" rtlCol="0" anchor="ctr"/>
           <a:lstStyle/>
           <a:p>
-            <a:pPr algn="ctr" indent="0" marL="0">
+            <a:pPr marL="0" indent="0" algn="ctr">
               <a:buNone/>
             </a:pPr>
             <a:r>
@@ -11140,7 +11095,7 @@
           </a:solidFill>
           <a:ln/>
           <a:effectLst>
-            <a:outerShdw sx="100000" sy="100000" kx="0" ky="0" algn="bl" rotWithShape="0" blurRad="101600" dist="38100" dir="8100000">
+            <a:outerShdw blurRad="101600" dist="38100" dir="8100000" algn="bl" rotWithShape="0">
               <a:srgbClr val="000000">
                 <a:alpha val="18000"/>
               </a:srgbClr>
@@ -11294,7 +11249,7 @@
           </a:solidFill>
           <a:ln/>
           <a:effectLst>
-            <a:outerShdw sx="100000" sy="100000" kx="0" ky="0" algn="bl" rotWithShape="0" blurRad="101600" dist="38100" dir="8100000">
+            <a:outerShdw blurRad="101600" dist="38100" dir="8100000" algn="bl" rotWithShape="0">
               <a:srgbClr val="000000">
                 <a:alpha val="18000"/>
               </a:srgbClr>
@@ -11323,7 +11278,7 @@
           <a:bodyPr wrap="square" lIns="0" tIns="0" rIns="0" bIns="0" rtlCol="0" anchor="ctr"/>
           <a:lstStyle/>
           <a:p>
-            <a:pPr algn="ctr" indent="0" marL="0">
+            <a:pPr marL="0" indent="0" algn="ctr">
               <a:buNone/>
             </a:pPr>
             <a:r>
@@ -11359,7 +11314,7 @@
           <a:bodyPr wrap="square" lIns="0" tIns="0" rIns="0" bIns="0" rtlCol="0" anchor="ctr"/>
           <a:lstStyle/>
           <a:p>
-            <a:pPr algn="ctr" indent="0" marL="0">
+            <a:pPr marL="0" indent="0" algn="ctr">
               <a:buNone/>
             </a:pPr>
             <a:r>
@@ -11393,7 +11348,7 @@
           </a:solidFill>
           <a:ln/>
           <a:effectLst>
-            <a:outerShdw sx="100000" sy="100000" kx="0" ky="0" algn="bl" rotWithShape="0" blurRad="101600" dist="38100" dir="8100000">
+            <a:outerShdw blurRad="101600" dist="38100" dir="8100000" algn="bl" rotWithShape="0">
               <a:srgbClr val="000000">
                 <a:alpha val="18000"/>
               </a:srgbClr>
@@ -11422,7 +11377,7 @@
           <a:bodyPr wrap="square" lIns="0" tIns="0" rIns="0" bIns="0" rtlCol="0" anchor="ctr"/>
           <a:lstStyle/>
           <a:p>
-            <a:pPr algn="ctr" indent="0" marL="0">
+            <a:pPr marL="0" indent="0" algn="ctr">
               <a:buNone/>
             </a:pPr>
             <a:r>
@@ -11458,7 +11413,7 @@
           <a:bodyPr wrap="square" lIns="0" tIns="0" rIns="0" bIns="0" rtlCol="0" anchor="ctr"/>
           <a:lstStyle/>
           <a:p>
-            <a:pPr algn="ctr" indent="0" marL="0">
+            <a:pPr marL="0" indent="0" algn="ctr">
               <a:buNone/>
             </a:pPr>
             <a:r>
@@ -11492,7 +11447,7 @@
           </a:solidFill>
           <a:ln/>
           <a:effectLst>
-            <a:outerShdw sx="100000" sy="100000" kx="0" ky="0" algn="bl" rotWithShape="0" blurRad="101600" dist="38100" dir="8100000">
+            <a:outerShdw blurRad="101600" dist="38100" dir="8100000" algn="bl" rotWithShape="0">
               <a:srgbClr val="000000">
                 <a:alpha val="18000"/>
               </a:srgbClr>
@@ -11521,7 +11476,7 @@
           <a:bodyPr wrap="square" lIns="0" tIns="0" rIns="0" bIns="0" rtlCol="0" anchor="ctr"/>
           <a:lstStyle/>
           <a:p>
-            <a:pPr algn="ctr" indent="0" marL="0">
+            <a:pPr marL="0" indent="0" algn="ctr">
               <a:buNone/>
             </a:pPr>
             <a:r>
@@ -11557,7 +11512,7 @@
           <a:bodyPr wrap="square" lIns="0" tIns="0" rIns="0" bIns="0" rtlCol="0" anchor="ctr"/>
           <a:lstStyle/>
           <a:p>
-            <a:pPr algn="ctr" indent="0" marL="0">
+            <a:pPr marL="0" indent="0" algn="ctr">
               <a:buNone/>
             </a:pPr>
             <a:r>
@@ -11616,7 +11571,7 @@
           <a:bodyPr wrap="square" rtlCol="0" anchor="ctr"/>
           <a:lstStyle/>
           <a:p>
-            <a:pPr indent="0" marL="0">
+            <a:pPr marL="0" indent="0">
               <a:buNone/>
             </a:pPr>
             <a:r>
@@ -11932,4 +11887,299 @@
     </a:ext>
   </a:extLst>
 </a:theme>
+</file>
+
+<file path=ppt/theme/theme2.xml><?xml version="1.0" encoding="utf-8"?>
+<a:theme xmlns:a="http://schemas.openxmlformats.org/drawingml/2006/main" name="Thème Office">
+  <a:themeElements>
+    <a:clrScheme name="Office">
+      <a:dk1>
+        <a:sysClr val="windowText" lastClr="000000"/>
+      </a:dk1>
+      <a:lt1>
+        <a:sysClr val="window" lastClr="FFFFFF"/>
+      </a:lt1>
+      <a:dk2>
+        <a:srgbClr val="44546A"/>
+      </a:dk2>
+      <a:lt2>
+        <a:srgbClr val="E7E6E6"/>
+      </a:lt2>
+      <a:accent1>
+        <a:srgbClr val="4472C4"/>
+      </a:accent1>
+      <a:accent2>
+        <a:srgbClr val="ED7D31"/>
+      </a:accent2>
+      <a:accent3>
+        <a:srgbClr val="A5A5A5"/>
+      </a:accent3>
+      <a:accent4>
+        <a:srgbClr val="FFC000"/>
+      </a:accent4>
+      <a:accent5>
+        <a:srgbClr val="5B9BD5"/>
+      </a:accent5>
+      <a:accent6>
+        <a:srgbClr val="70AD47"/>
+      </a:accent6>
+      <a:hlink>
+        <a:srgbClr val="0563C1"/>
+      </a:hlink>
+      <a:folHlink>
+        <a:srgbClr val="954F72"/>
+      </a:folHlink>
+    </a:clrScheme>
+    <a:fontScheme name="Office">
+      <a:majorFont>
+        <a:latin typeface="Calibri Light" panose="020F0302020204030204"/>
+        <a:ea typeface=""/>
+        <a:cs typeface=""/>
+        <a:font script="Jpan" typeface="游ゴシック Light"/>
+        <a:font script="Hang" typeface="맑은 고딕"/>
+        <a:font script="Hans" typeface="等线 Light"/>
+        <a:font script="Hant" typeface="新細明體"/>
+        <a:font script="Arab" typeface="Times New Roman"/>
+        <a:font script="Hebr" typeface="Times New Roman"/>
+        <a:font script="Thai" typeface="Angsana New"/>
+        <a:font script="Ethi" typeface="Nyala"/>
+        <a:font script="Beng" typeface="Vrinda"/>
+        <a:font script="Gujr" typeface="Shruti"/>
+        <a:font script="Khmr" typeface="MoolBoran"/>
+        <a:font script="Knda" typeface="Tunga"/>
+        <a:font script="Guru" typeface="Raavi"/>
+        <a:font script="Cans" typeface="Euphemia"/>
+        <a:font script="Cher" typeface="Plantagenet Cherokee"/>
+        <a:font script="Yiii" typeface="Microsoft Yi Baiti"/>
+        <a:font script="Tibt" typeface="Microsoft Himalaya"/>
+        <a:font script="Thaa" typeface="MV Boli"/>
+        <a:font script="Deva" typeface="Mangal"/>
+        <a:font script="Telu" typeface="Gautami"/>
+        <a:font script="Taml" typeface="Latha"/>
+        <a:font script="Syrc" typeface="Estrangelo Edessa"/>
+        <a:font script="Orya" typeface="Kalinga"/>
+        <a:font script="Mlym" typeface="Kartika"/>
+        <a:font script="Laoo" typeface="DokChampa"/>
+        <a:font script="Sinh" typeface="Iskoola Pota"/>
+        <a:font script="Mong" typeface="Mongolian Baiti"/>
+        <a:font script="Viet" typeface="Times New Roman"/>
+        <a:font script="Uigh" typeface="Microsoft Uighur"/>
+        <a:font script="Geor" typeface="Sylfaen"/>
+        <a:font script="Armn" typeface="Arial"/>
+        <a:font script="Bugi" typeface="Leelawadee UI"/>
+        <a:font script="Bopo" typeface="Microsoft JhengHei"/>
+        <a:font script="Java" typeface="Javanese Text"/>
+        <a:font script="Lisu" typeface="Segoe UI"/>
+        <a:font script="Mymr" typeface="Myanmar Text"/>
+        <a:font script="Nkoo" typeface="Ebrima"/>
+        <a:font script="Olck" typeface="Nirmala UI"/>
+        <a:font script="Osma" typeface="Ebrima"/>
+        <a:font script="Phag" typeface="Phagspa"/>
+        <a:font script="Syrn" typeface="Estrangelo Edessa"/>
+        <a:font script="Syrj" typeface="Estrangelo Edessa"/>
+        <a:font script="Syre" typeface="Estrangelo Edessa"/>
+        <a:font script="Sora" typeface="Nirmala UI"/>
+        <a:font script="Tale" typeface="Microsoft Tai Le"/>
+        <a:font script="Talu" typeface="Microsoft New Tai Lue"/>
+        <a:font script="Tfng" typeface="Ebrima"/>
+      </a:majorFont>
+      <a:minorFont>
+        <a:latin typeface="Calibri" panose="020F0502020204030204"/>
+        <a:ea typeface=""/>
+        <a:cs typeface=""/>
+        <a:font script="Jpan" typeface="游ゴシック"/>
+        <a:font script="Hang" typeface="맑은 고딕"/>
+        <a:font script="Hans" typeface="等线"/>
+        <a:font script="Hant" typeface="新細明體"/>
+        <a:font script="Arab" typeface="Arial"/>
+        <a:font script="Hebr" typeface="Arial"/>
+        <a:font script="Thai" typeface="Cordia New"/>
+        <a:font script="Ethi" typeface="Nyala"/>
+        <a:font script="Beng" typeface="Vrinda"/>
+        <a:font script="Gujr" typeface="Shruti"/>
+        <a:font script="Khmr" typeface="DaunPenh"/>
+        <a:font script="Knda" typeface="Tunga"/>
+        <a:font script="Guru" typeface="Raavi"/>
+        <a:font script="Cans" typeface="Euphemia"/>
+        <a:font script="Cher" typeface="Plantagenet Cherokee"/>
+        <a:font script="Yiii" typeface="Microsoft Yi Baiti"/>
+        <a:font script="Tibt" typeface="Microsoft Himalaya"/>
+        <a:font script="Thaa" typeface="MV Boli"/>
+        <a:font script="Deva" typeface="Mangal"/>
+        <a:font script="Telu" typeface="Gautami"/>
+        <a:font script="Taml" typeface="Latha"/>
+        <a:font script="Syrc" typeface="Estrangelo Edessa"/>
+        <a:font script="Orya" typeface="Kalinga"/>
+        <a:font script="Mlym" typeface="Kartika"/>
+        <a:font script="Laoo" typeface="DokChampa"/>
+        <a:font script="Sinh" typeface="Iskoola Pota"/>
+        <a:font script="Mong" typeface="Mongolian Baiti"/>
+        <a:font script="Viet" typeface="Arial"/>
+        <a:font script="Uigh" typeface="Microsoft Uighur"/>
+        <a:font script="Geor" typeface="Sylfaen"/>
+        <a:font script="Armn" typeface="Arial"/>
+        <a:font script="Bugi" typeface="Leelawadee UI"/>
+        <a:font script="Bopo" typeface="Microsoft JhengHei"/>
+        <a:font script="Java" typeface="Javanese Text"/>
+        <a:font script="Lisu" typeface="Segoe UI"/>
+        <a:font script="Mymr" typeface="Myanmar Text"/>
+        <a:font script="Nkoo" typeface="Ebrima"/>
+        <a:font script="Olck" typeface="Nirmala UI"/>
+        <a:font script="Osma" typeface="Ebrima"/>
+        <a:font script="Phag" typeface="Phagspa"/>
+        <a:font script="Syrn" typeface="Estrangelo Edessa"/>
+        <a:font script="Syrj" typeface="Estrangelo Edessa"/>
+        <a:font script="Syre" typeface="Estrangelo Edessa"/>
+        <a:font script="Sora" typeface="Nirmala UI"/>
+        <a:font script="Tale" typeface="Microsoft Tai Le"/>
+        <a:font script="Talu" typeface="Microsoft New Tai Lue"/>
+        <a:font script="Tfng" typeface="Ebrima"/>
+      </a:minorFont>
+    </a:fontScheme>
+    <a:fmtScheme name="Office">
+      <a:fillStyleLst>
+        <a:solidFill>
+          <a:schemeClr val="phClr"/>
+        </a:solidFill>
+        <a:gradFill rotWithShape="1">
+          <a:gsLst>
+            <a:gs pos="0">
+              <a:schemeClr val="phClr">
+                <a:lumMod val="110000"/>
+                <a:satMod val="105000"/>
+                <a:tint val="67000"/>
+              </a:schemeClr>
+            </a:gs>
+            <a:gs pos="50000">
+              <a:schemeClr val="phClr">
+                <a:lumMod val="105000"/>
+                <a:satMod val="103000"/>
+                <a:tint val="73000"/>
+              </a:schemeClr>
+            </a:gs>
+            <a:gs pos="100000">
+              <a:schemeClr val="phClr">
+                <a:lumMod val="105000"/>
+                <a:satMod val="109000"/>
+                <a:tint val="81000"/>
+              </a:schemeClr>
+            </a:gs>
+          </a:gsLst>
+          <a:lin ang="5400000" scaled="0"/>
+        </a:gradFill>
+        <a:gradFill rotWithShape="1">
+          <a:gsLst>
+            <a:gs pos="0">
+              <a:schemeClr val="phClr">
+                <a:satMod val="103000"/>
+                <a:lumMod val="102000"/>
+                <a:tint val="94000"/>
+              </a:schemeClr>
+            </a:gs>
+            <a:gs pos="50000">
+              <a:schemeClr val="phClr">
+                <a:satMod val="110000"/>
+                <a:lumMod val="100000"/>
+                <a:shade val="100000"/>
+              </a:schemeClr>
+            </a:gs>
+            <a:gs pos="100000">
+              <a:schemeClr val="phClr">
+                <a:lumMod val="99000"/>
+                <a:satMod val="120000"/>
+                <a:shade val="78000"/>
+              </a:schemeClr>
+            </a:gs>
+          </a:gsLst>
+          <a:lin ang="5400000" scaled="0"/>
+        </a:gradFill>
+      </a:fillStyleLst>
+      <a:lnStyleLst>
+        <a:ln w="6350" cap="flat" cmpd="sng" algn="ctr">
+          <a:solidFill>
+            <a:schemeClr val="phClr"/>
+          </a:solidFill>
+          <a:prstDash val="solid"/>
+          <a:miter lim="800000"/>
+        </a:ln>
+        <a:ln w="12700" cap="flat" cmpd="sng" algn="ctr">
+          <a:solidFill>
+            <a:schemeClr val="phClr"/>
+          </a:solidFill>
+          <a:prstDash val="solid"/>
+          <a:miter lim="800000"/>
+        </a:ln>
+        <a:ln w="19050" cap="flat" cmpd="sng" algn="ctr">
+          <a:solidFill>
+            <a:schemeClr val="phClr"/>
+          </a:solidFill>
+          <a:prstDash val="solid"/>
+          <a:miter lim="800000"/>
+        </a:ln>
+      </a:lnStyleLst>
+      <a:effectStyleLst>
+        <a:effectStyle>
+          <a:effectLst/>
+        </a:effectStyle>
+        <a:effectStyle>
+          <a:effectLst/>
+        </a:effectStyle>
+        <a:effectStyle>
+          <a:effectLst>
+            <a:outerShdw blurRad="57150" dist="19050" dir="5400000" algn="ctr" rotWithShape="0">
+              <a:srgbClr val="000000">
+                <a:alpha val="63000"/>
+              </a:srgbClr>
+            </a:outerShdw>
+          </a:effectLst>
+        </a:effectStyle>
+      </a:effectStyleLst>
+      <a:bgFillStyleLst>
+        <a:solidFill>
+          <a:schemeClr val="phClr"/>
+        </a:solidFill>
+        <a:solidFill>
+          <a:schemeClr val="phClr">
+            <a:tint val="95000"/>
+            <a:satMod val="170000"/>
+          </a:schemeClr>
+        </a:solidFill>
+        <a:gradFill rotWithShape="1">
+          <a:gsLst>
+            <a:gs pos="0">
+              <a:schemeClr val="phClr">
+                <a:tint val="93000"/>
+                <a:satMod val="150000"/>
+                <a:shade val="98000"/>
+                <a:lumMod val="102000"/>
+              </a:schemeClr>
+            </a:gs>
+            <a:gs pos="50000">
+              <a:schemeClr val="phClr">
+                <a:tint val="98000"/>
+                <a:satMod val="130000"/>
+                <a:shade val="90000"/>
+                <a:lumMod val="103000"/>
+              </a:schemeClr>
+            </a:gs>
+            <a:gs pos="100000">
+              <a:schemeClr val="phClr">
+                <a:shade val="63000"/>
+                <a:satMod val="120000"/>
+              </a:schemeClr>
+            </a:gs>
+          </a:gsLst>
+          <a:lin ang="5400000" scaled="0"/>
+        </a:gradFill>
+      </a:bgFillStyleLst>
+    </a:fmtScheme>
+  </a:themeElements>
+  <a:objectDefaults/>
+  <a:extraClrSchemeLst/>
+  <a:extLst>
+    <a:ext uri="{05A4C25C-085E-4340-85A3-A5531E510DB2}">
+      <thm15:themeFamily xmlns:thm15="http://schemas.microsoft.com/office/thememl/2012/main" name="Office Theme" id="{62F939B6-93AF-4DB8-9C6B-D6C7DFDC589F}" vid="{4A3C46E8-61CC-4603-A589-7422A47A8E4A}"/>
+    </a:ext>
+  </a:extLst>
+</a:theme>
 </file>
</xml_diff>